<commit_message>
[fix] Update slide animation for rebase and remove code exercise
</commit_message>
<xml_diff>
--- a/Slides/MiCM_GitHub_Workshop_sept_2026.pptx
+++ b/Slides/MiCM_GitHub_Workshop_sept_2026.pptx
@@ -5,7 +5,7 @@
     <p:sldMasterId id="2147483672" r:id="rId1"/>
   </p:sldMasterIdLst>
   <p:notesMasterIdLst>
-    <p:notesMasterId r:id="rId86"/>
+    <p:notesMasterId r:id="rId87"/>
   </p:notesMasterIdLst>
   <p:sldIdLst>
     <p:sldId id="316" r:id="rId2"/>
@@ -44,54 +44,55 @@
     <p:sldId id="337" r:id="rId35"/>
     <p:sldId id="375" r:id="rId36"/>
     <p:sldId id="338" r:id="rId37"/>
-    <p:sldId id="425" r:id="rId38"/>
-    <p:sldId id="424" r:id="rId39"/>
-    <p:sldId id="362" r:id="rId40"/>
-    <p:sldId id="345" r:id="rId41"/>
-    <p:sldId id="376" r:id="rId42"/>
-    <p:sldId id="364" r:id="rId43"/>
-    <p:sldId id="363" r:id="rId44"/>
-    <p:sldId id="324" r:id="rId45"/>
-    <p:sldId id="368" r:id="rId46"/>
-    <p:sldId id="328" r:id="rId47"/>
-    <p:sldId id="326" r:id="rId48"/>
-    <p:sldId id="402" r:id="rId49"/>
-    <p:sldId id="403" r:id="rId50"/>
-    <p:sldId id="346" r:id="rId51"/>
-    <p:sldId id="377" r:id="rId52"/>
-    <p:sldId id="347" r:id="rId53"/>
-    <p:sldId id="378" r:id="rId54"/>
-    <p:sldId id="358" r:id="rId55"/>
-    <p:sldId id="404" r:id="rId56"/>
-    <p:sldId id="348" r:id="rId57"/>
-    <p:sldId id="379" r:id="rId58"/>
-    <p:sldId id="414" r:id="rId59"/>
-    <p:sldId id="415" r:id="rId60"/>
-    <p:sldId id="401" r:id="rId61"/>
-    <p:sldId id="406" r:id="rId62"/>
-    <p:sldId id="359" r:id="rId63"/>
-    <p:sldId id="405" r:id="rId64"/>
-    <p:sldId id="350" r:id="rId65"/>
-    <p:sldId id="380" r:id="rId66"/>
-    <p:sldId id="367" r:id="rId67"/>
-    <p:sldId id="410" r:id="rId68"/>
-    <p:sldId id="391" r:id="rId69"/>
-    <p:sldId id="382" r:id="rId70"/>
-    <p:sldId id="407" r:id="rId71"/>
-    <p:sldId id="383" r:id="rId72"/>
-    <p:sldId id="392" r:id="rId73"/>
-    <p:sldId id="384" r:id="rId74"/>
-    <p:sldId id="385" r:id="rId75"/>
-    <p:sldId id="386" r:id="rId76"/>
-    <p:sldId id="388" r:id="rId77"/>
-    <p:sldId id="393" r:id="rId78"/>
-    <p:sldId id="390" r:id="rId79"/>
-    <p:sldId id="394" r:id="rId80"/>
-    <p:sldId id="329" r:id="rId81"/>
-    <p:sldId id="330" r:id="rId82"/>
-    <p:sldId id="331" r:id="rId83"/>
-    <p:sldId id="421" r:id="rId84"/>
-    <p:sldId id="342" r:id="rId85"/>
+    <p:sldId id="426" r:id="rId38"/>
+    <p:sldId id="425" r:id="rId39"/>
+    <p:sldId id="424" r:id="rId40"/>
+    <p:sldId id="362" r:id="rId41"/>
+    <p:sldId id="345" r:id="rId42"/>
+    <p:sldId id="376" r:id="rId43"/>
+    <p:sldId id="364" r:id="rId44"/>
+    <p:sldId id="363" r:id="rId45"/>
+    <p:sldId id="324" r:id="rId46"/>
+    <p:sldId id="368" r:id="rId47"/>
+    <p:sldId id="328" r:id="rId48"/>
+    <p:sldId id="326" r:id="rId49"/>
+    <p:sldId id="402" r:id="rId50"/>
+    <p:sldId id="403" r:id="rId51"/>
+    <p:sldId id="346" r:id="rId52"/>
+    <p:sldId id="377" r:id="rId53"/>
+    <p:sldId id="347" r:id="rId54"/>
+    <p:sldId id="378" r:id="rId55"/>
+    <p:sldId id="358" r:id="rId56"/>
+    <p:sldId id="404" r:id="rId57"/>
+    <p:sldId id="348" r:id="rId58"/>
+    <p:sldId id="379" r:id="rId59"/>
+    <p:sldId id="414" r:id="rId60"/>
+    <p:sldId id="415" r:id="rId61"/>
+    <p:sldId id="401" r:id="rId62"/>
+    <p:sldId id="406" r:id="rId63"/>
+    <p:sldId id="359" r:id="rId64"/>
+    <p:sldId id="405" r:id="rId65"/>
+    <p:sldId id="350" r:id="rId66"/>
+    <p:sldId id="380" r:id="rId67"/>
+    <p:sldId id="367" r:id="rId68"/>
+    <p:sldId id="410" r:id="rId69"/>
+    <p:sldId id="391" r:id="rId70"/>
+    <p:sldId id="382" r:id="rId71"/>
+    <p:sldId id="407" r:id="rId72"/>
+    <p:sldId id="383" r:id="rId73"/>
+    <p:sldId id="392" r:id="rId74"/>
+    <p:sldId id="384" r:id="rId75"/>
+    <p:sldId id="385" r:id="rId76"/>
+    <p:sldId id="386" r:id="rId77"/>
+    <p:sldId id="388" r:id="rId78"/>
+    <p:sldId id="393" r:id="rId79"/>
+    <p:sldId id="390" r:id="rId80"/>
+    <p:sldId id="394" r:id="rId81"/>
+    <p:sldId id="329" r:id="rId82"/>
+    <p:sldId id="330" r:id="rId83"/>
+    <p:sldId id="331" r:id="rId84"/>
+    <p:sldId id="421" r:id="rId85"/>
+    <p:sldId id="342" r:id="rId86"/>
   </p:sldIdLst>
   <p:sldSz cx="9144000" cy="6858000" type="screen4x3"/>
   <p:notesSz cx="6858000" cy="9144000"/>
@@ -198,12 +199,20 @@
 </p:presentation>
 </file>
 
+<file path=ppt/revisionInfo.xml><?xml version="1.0" encoding="utf-8"?>
+<p1510:revInfo xmlns:a="http://schemas.openxmlformats.org/drawingml/2006/main" xmlns:r="http://schemas.openxmlformats.org/officeDocument/2006/relationships" xmlns:p1510="http://schemas.microsoft.com/office/powerpoint/2015/10/main">
+  <p1510:revLst>
+    <p1510:client id="{ED33159D-BD55-4850-BF2D-D8FBB1361ACF}" v="36" dt="2026-09-21T16:42:42.423"/>
+  </p1510:revLst>
+</p1510:revInfo>
+</file>
+
 <file path=ppt/changesInfos/changesInfo1.xml><?xml version="1.0" encoding="utf-8"?>
 <pc:chgInfo xmlns:a="http://schemas.openxmlformats.org/drawingml/2006/main" xmlns:r="http://schemas.openxmlformats.org/officeDocument/2006/relationships" xmlns:ac="http://schemas.microsoft.com/office/drawing/2013/main/command" xmlns:pc="http://schemas.microsoft.com/office/powerpoint/2013/main/command">
   <pc:docChgLst>
     <pc:chgData name="Eric Huang" userId="3b01fa70-91e3-4d29-852b-56bc423b811b" providerId="ADAL" clId="{2BF4BDDA-F1A4-44EE-95EA-21AFC6EDF82F}"/>
     <pc:docChg chg="undo custSel addSld delSld modSld">
-      <pc:chgData name="Eric Huang" userId="3b01fa70-91e3-4d29-852b-56bc423b811b" providerId="ADAL" clId="{2BF4BDDA-F1A4-44EE-95EA-21AFC6EDF82F}" dt="2026-09-21T15:30:21.226" v="2701" actId="20577"/>
+      <pc:chgData name="Eric Huang" userId="3b01fa70-91e3-4d29-852b-56bc423b811b" providerId="ADAL" clId="{2BF4BDDA-F1A4-44EE-95EA-21AFC6EDF82F}" dt="2026-09-21T16:42:42.407" v="2776" actId="20577"/>
       <pc:docMkLst>
         <pc:docMk/>
       </pc:docMkLst>
@@ -221,6 +230,238 @@
             <ac:spMk id="3" creationId="{E7537085-13D1-FBF7-FC22-14EA9C5F5578}"/>
           </ac:spMkLst>
         </pc:spChg>
+      </pc:sldChg>
+      <pc:sldChg chg="delSp modSp mod modAnim">
+        <pc:chgData name="Eric Huang" userId="3b01fa70-91e3-4d29-852b-56bc423b811b" providerId="ADAL" clId="{2BF4BDDA-F1A4-44EE-95EA-21AFC6EDF82F}" dt="2026-09-21T16:35:47.407" v="2722" actId="478"/>
+        <pc:sldMkLst>
+          <pc:docMk/>
+          <pc:sldMk cId="2209846115" sldId="338"/>
+        </pc:sldMkLst>
+        <pc:spChg chg="mod">
+          <ac:chgData name="Eric Huang" userId="3b01fa70-91e3-4d29-852b-56bc423b811b" providerId="ADAL" clId="{2BF4BDDA-F1A4-44EE-95EA-21AFC6EDF82F}" dt="2026-09-21T16:35:39.871" v="2718" actId="1036"/>
+          <ac:spMkLst>
+            <pc:docMk/>
+            <pc:sldMk cId="2209846115" sldId="338"/>
+            <ac:spMk id="15" creationId="{DF1D212D-D57A-6288-056C-CB6CDEDC3C92}"/>
+          </ac:spMkLst>
+        </pc:spChg>
+        <pc:spChg chg="del">
+          <ac:chgData name="Eric Huang" userId="3b01fa70-91e3-4d29-852b-56bc423b811b" providerId="ADAL" clId="{2BF4BDDA-F1A4-44EE-95EA-21AFC6EDF82F}" dt="2026-09-21T16:35:36.837" v="2708" actId="478"/>
+          <ac:spMkLst>
+            <pc:docMk/>
+            <pc:sldMk cId="2209846115" sldId="338"/>
+            <ac:spMk id="18" creationId="{1613281B-8113-9487-9C79-9DF26C91CB96}"/>
+          </ac:spMkLst>
+        </pc:spChg>
+        <pc:spChg chg="del">
+          <ac:chgData name="Eric Huang" userId="3b01fa70-91e3-4d29-852b-56bc423b811b" providerId="ADAL" clId="{2BF4BDDA-F1A4-44EE-95EA-21AFC6EDF82F}" dt="2026-09-21T16:35:42.365" v="2719" actId="478"/>
+          <ac:spMkLst>
+            <pc:docMk/>
+            <pc:sldMk cId="2209846115" sldId="338"/>
+            <ac:spMk id="19" creationId="{F6BB5A0B-BC5C-E442-9063-B99E7446667B}"/>
+          </ac:spMkLst>
+        </pc:spChg>
+        <pc:spChg chg="del">
+          <ac:chgData name="Eric Huang" userId="3b01fa70-91e3-4d29-852b-56bc423b811b" providerId="ADAL" clId="{2BF4BDDA-F1A4-44EE-95EA-21AFC6EDF82F}" dt="2026-09-21T16:35:44.145" v="2720" actId="478"/>
+          <ac:spMkLst>
+            <pc:docMk/>
+            <pc:sldMk cId="2209846115" sldId="338"/>
+            <ac:spMk id="28" creationId="{4784692F-2F03-22AB-E104-B49B3B9D5442}"/>
+          </ac:spMkLst>
+        </pc:spChg>
+        <pc:cxnChg chg="del mod">
+          <ac:chgData name="Eric Huang" userId="3b01fa70-91e3-4d29-852b-56bc423b811b" providerId="ADAL" clId="{2BF4BDDA-F1A4-44EE-95EA-21AFC6EDF82F}" dt="2026-09-21T16:35:45.972" v="2721" actId="478"/>
+          <ac:cxnSpMkLst>
+            <pc:docMk/>
+            <pc:sldMk cId="2209846115" sldId="338"/>
+            <ac:cxnSpMk id="20" creationId="{9BD6F78C-8910-1110-F11E-4A9319F45E9E}"/>
+          </ac:cxnSpMkLst>
+        </pc:cxnChg>
+        <pc:cxnChg chg="del mod">
+          <ac:chgData name="Eric Huang" userId="3b01fa70-91e3-4d29-852b-56bc423b811b" providerId="ADAL" clId="{2BF4BDDA-F1A4-44EE-95EA-21AFC6EDF82F}" dt="2026-09-21T16:35:47.407" v="2722" actId="478"/>
+          <ac:cxnSpMkLst>
+            <pc:docMk/>
+            <pc:sldMk cId="2209846115" sldId="338"/>
+            <ac:cxnSpMk id="21" creationId="{AAC45847-195B-CE42-5589-B239965E542C}"/>
+          </ac:cxnSpMkLst>
+        </pc:cxnChg>
+      </pc:sldChg>
+      <pc:sldChg chg="modSp mod">
+        <pc:chgData name="Eric Huang" userId="3b01fa70-91e3-4d29-852b-56bc423b811b" providerId="ADAL" clId="{2BF4BDDA-F1A4-44EE-95EA-21AFC6EDF82F}" dt="2026-09-21T16:39:01.611" v="2755" actId="20577"/>
+        <pc:sldMkLst>
+          <pc:docMk/>
+          <pc:sldMk cId="4007831989" sldId="350"/>
+        </pc:sldMkLst>
+        <pc:spChg chg="mod">
+          <ac:chgData name="Eric Huang" userId="3b01fa70-91e3-4d29-852b-56bc423b811b" providerId="ADAL" clId="{2BF4BDDA-F1A4-44EE-95EA-21AFC6EDF82F}" dt="2026-09-21T16:39:01.611" v="2755" actId="20577"/>
+          <ac:spMkLst>
+            <pc:docMk/>
+            <pc:sldMk cId="4007831989" sldId="350"/>
+            <ac:spMk id="2" creationId="{F30F071A-0450-8F6E-F28D-8124D7A90523}"/>
+          </ac:spMkLst>
+        </pc:spChg>
+      </pc:sldChg>
+      <pc:sldChg chg="modSp modAnim">
+        <pc:chgData name="Eric Huang" userId="3b01fa70-91e3-4d29-852b-56bc423b811b" providerId="ADAL" clId="{2BF4BDDA-F1A4-44EE-95EA-21AFC6EDF82F}" dt="2026-09-21T16:42:42.407" v="2776" actId="20577"/>
+        <pc:sldMkLst>
+          <pc:docMk/>
+          <pc:sldMk cId="1411733175" sldId="380"/>
+        </pc:sldMkLst>
+        <pc:spChg chg="mod">
+          <ac:chgData name="Eric Huang" userId="3b01fa70-91e3-4d29-852b-56bc423b811b" providerId="ADAL" clId="{2BF4BDDA-F1A4-44EE-95EA-21AFC6EDF82F}" dt="2026-09-21T16:42:42.407" v="2776" actId="20577"/>
+          <ac:spMkLst>
+            <pc:docMk/>
+            <pc:sldMk cId="1411733175" sldId="380"/>
+            <ac:spMk id="2" creationId="{F30F071A-0450-8F6E-F28D-8124D7A90523}"/>
+          </ac:spMkLst>
+        </pc:spChg>
+      </pc:sldChg>
+      <pc:sldChg chg="mod modShow">
+        <pc:chgData name="Eric Huang" userId="3b01fa70-91e3-4d29-852b-56bc423b811b" providerId="ADAL" clId="{2BF4BDDA-F1A4-44EE-95EA-21AFC6EDF82F}" dt="2026-09-21T16:38:16.476" v="2745" actId="729"/>
+        <pc:sldMkLst>
+          <pc:docMk/>
+          <pc:sldMk cId="1071182491" sldId="401"/>
+        </pc:sldMkLst>
+      </pc:sldChg>
+      <pc:sldChg chg="modSp">
+        <pc:chgData name="Eric Huang" userId="3b01fa70-91e3-4d29-852b-56bc423b811b" providerId="ADAL" clId="{2BF4BDDA-F1A4-44EE-95EA-21AFC6EDF82F}" dt="2026-09-21T16:40:58.090" v="2771" actId="20577"/>
+        <pc:sldMkLst>
+          <pc:docMk/>
+          <pc:sldMk cId="3096863422" sldId="406"/>
+        </pc:sldMkLst>
+        <pc:spChg chg="mod">
+          <ac:chgData name="Eric Huang" userId="3b01fa70-91e3-4d29-852b-56bc423b811b" providerId="ADAL" clId="{2BF4BDDA-F1A4-44EE-95EA-21AFC6EDF82F}" dt="2026-09-21T16:40:58.090" v="2771" actId="20577"/>
+          <ac:spMkLst>
+            <pc:docMk/>
+            <pc:sldMk cId="3096863422" sldId="406"/>
+            <ac:spMk id="2" creationId="{B23CE1A8-4666-C14A-4847-394F06186EB9}"/>
+          </ac:spMkLst>
+        </pc:spChg>
+      </pc:sldChg>
+      <pc:sldChg chg="modSp">
+        <pc:chgData name="Eric Huang" userId="3b01fa70-91e3-4d29-852b-56bc423b811b" providerId="ADAL" clId="{2BF4BDDA-F1A4-44EE-95EA-21AFC6EDF82F}" dt="2026-09-21T16:41:02.463" v="2774" actId="20577"/>
+        <pc:sldMkLst>
+          <pc:docMk/>
+          <pc:sldMk cId="1686466894" sldId="414"/>
+        </pc:sldMkLst>
+        <pc:spChg chg="mod">
+          <ac:chgData name="Eric Huang" userId="3b01fa70-91e3-4d29-852b-56bc423b811b" providerId="ADAL" clId="{2BF4BDDA-F1A4-44EE-95EA-21AFC6EDF82F}" dt="2026-09-21T16:41:02.463" v="2774" actId="20577"/>
+          <ac:spMkLst>
+            <pc:docMk/>
+            <pc:sldMk cId="1686466894" sldId="414"/>
+            <ac:spMk id="2" creationId="{343751EF-D081-B173-BEF1-BAD54401CDA4}"/>
+          </ac:spMkLst>
+        </pc:spChg>
+      </pc:sldChg>
+      <pc:sldChg chg="mod modShow">
+        <pc:chgData name="Eric Huang" userId="3b01fa70-91e3-4d29-852b-56bc423b811b" providerId="ADAL" clId="{2BF4BDDA-F1A4-44EE-95EA-21AFC6EDF82F}" dt="2026-09-21T16:38:16.476" v="2745" actId="729"/>
+        <pc:sldMkLst>
+          <pc:docMk/>
+          <pc:sldMk cId="3592577252" sldId="415"/>
+        </pc:sldMkLst>
+      </pc:sldChg>
+      <pc:sldChg chg="addSp delSp modSp add mod">
+        <pc:chgData name="Eric Huang" userId="3b01fa70-91e3-4d29-852b-56bc423b811b" providerId="ADAL" clId="{2BF4BDDA-F1A4-44EE-95EA-21AFC6EDF82F}" dt="2026-09-21T16:36:56.423" v="2744" actId="14100"/>
+        <pc:sldMkLst>
+          <pc:docMk/>
+          <pc:sldMk cId="3455594871" sldId="426"/>
+        </pc:sldMkLst>
+        <pc:spChg chg="mod">
+          <ac:chgData name="Eric Huang" userId="3b01fa70-91e3-4d29-852b-56bc423b811b" providerId="ADAL" clId="{2BF4BDDA-F1A4-44EE-95EA-21AFC6EDF82F}" dt="2026-09-21T16:36:05.357" v="2727" actId="1076"/>
+          <ac:spMkLst>
+            <pc:docMk/>
+            <pc:sldMk cId="3455594871" sldId="426"/>
+            <ac:spMk id="4" creationId="{A42DBF82-F560-3A67-AC19-919EEA1318F5}"/>
+          </ac:spMkLst>
+        </pc:spChg>
+        <pc:spChg chg="mod">
+          <ac:chgData name="Eric Huang" userId="3b01fa70-91e3-4d29-852b-56bc423b811b" providerId="ADAL" clId="{2BF4BDDA-F1A4-44EE-95EA-21AFC6EDF82F}" dt="2026-09-21T16:36:38.158" v="2739" actId="1076"/>
+          <ac:spMkLst>
+            <pc:docMk/>
+            <pc:sldMk cId="3455594871" sldId="426"/>
+            <ac:spMk id="8" creationId="{39B98A08-4295-110D-53BF-291B26A9D413}"/>
+          </ac:spMkLst>
+        </pc:spChg>
+        <pc:spChg chg="del">
+          <ac:chgData name="Eric Huang" userId="3b01fa70-91e3-4d29-852b-56bc423b811b" providerId="ADAL" clId="{2BF4BDDA-F1A4-44EE-95EA-21AFC6EDF82F}" dt="2026-09-21T16:35:51.438" v="2723" actId="478"/>
+          <ac:spMkLst>
+            <pc:docMk/>
+            <pc:sldMk cId="3455594871" sldId="426"/>
+            <ac:spMk id="15" creationId="{F693EC70-BCF7-0ED5-59BB-9127CCAD0DED}"/>
+          </ac:spMkLst>
+        </pc:spChg>
+        <pc:spChg chg="mod">
+          <ac:chgData name="Eric Huang" userId="3b01fa70-91e3-4d29-852b-56bc423b811b" providerId="ADAL" clId="{2BF4BDDA-F1A4-44EE-95EA-21AFC6EDF82F}" dt="2026-09-21T16:36:09.990" v="2729" actId="1076"/>
+          <ac:spMkLst>
+            <pc:docMk/>
+            <pc:sldMk cId="3455594871" sldId="426"/>
+            <ac:spMk id="18" creationId="{BE15A547-BACE-EAB5-BCD2-51764D129DF7}"/>
+          </ac:spMkLst>
+        </pc:spChg>
+        <pc:spChg chg="del">
+          <ac:chgData name="Eric Huang" userId="3b01fa70-91e3-4d29-852b-56bc423b811b" providerId="ADAL" clId="{2BF4BDDA-F1A4-44EE-95EA-21AFC6EDF82F}" dt="2026-09-21T16:36:30.995" v="2736" actId="478"/>
+          <ac:spMkLst>
+            <pc:docMk/>
+            <pc:sldMk cId="3455594871" sldId="426"/>
+            <ac:spMk id="19" creationId="{9BC0B97F-43E8-EB44-6EB7-A5E03082B69A}"/>
+          </ac:spMkLst>
+        </pc:spChg>
+        <pc:spChg chg="add del mod">
+          <ac:chgData name="Eric Huang" userId="3b01fa70-91e3-4d29-852b-56bc423b811b" providerId="ADAL" clId="{2BF4BDDA-F1A4-44EE-95EA-21AFC6EDF82F}" dt="2026-09-21T16:36:44.424" v="2740" actId="478"/>
+          <ac:spMkLst>
+            <pc:docMk/>
+            <pc:sldMk cId="3455594871" sldId="426"/>
+            <ac:spMk id="23" creationId="{4F53D951-E074-8828-F1FD-F75BC192E2F6}"/>
+          </ac:spMkLst>
+        </pc:spChg>
+        <pc:spChg chg="del">
+          <ac:chgData name="Eric Huang" userId="3b01fa70-91e3-4d29-852b-56bc423b811b" providerId="ADAL" clId="{2BF4BDDA-F1A4-44EE-95EA-21AFC6EDF82F}" dt="2026-09-21T16:36:29.973" v="2735" actId="478"/>
+          <ac:spMkLst>
+            <pc:docMk/>
+            <pc:sldMk cId="3455594871" sldId="426"/>
+            <ac:spMk id="28" creationId="{ED281B45-936C-3727-F9B8-FB0DBB5F410D}"/>
+          </ac:spMkLst>
+        </pc:spChg>
+        <pc:cxnChg chg="mod">
+          <ac:chgData name="Eric Huang" userId="3b01fa70-91e3-4d29-852b-56bc423b811b" providerId="ADAL" clId="{2BF4BDDA-F1A4-44EE-95EA-21AFC6EDF82F}" dt="2026-09-21T16:36:56.423" v="2744" actId="14100"/>
+          <ac:cxnSpMkLst>
+            <pc:docMk/>
+            <pc:sldMk cId="3455594871" sldId="426"/>
+            <ac:cxnSpMk id="6" creationId="{B8C19822-3CFA-2A95-AF98-44B5E9AEAF7F}"/>
+          </ac:cxnSpMkLst>
+        </pc:cxnChg>
+        <pc:cxnChg chg="mod">
+          <ac:chgData name="Eric Huang" userId="3b01fa70-91e3-4d29-852b-56bc423b811b" providerId="ADAL" clId="{2BF4BDDA-F1A4-44EE-95EA-21AFC6EDF82F}" dt="2026-09-21T16:36:38.158" v="2739" actId="1076"/>
+          <ac:cxnSpMkLst>
+            <pc:docMk/>
+            <pc:sldMk cId="3455594871" sldId="426"/>
+            <ac:cxnSpMk id="10" creationId="{29313149-C444-9BBA-56B4-B9E6812B1D16}"/>
+          </ac:cxnSpMkLst>
+        </pc:cxnChg>
+        <pc:cxnChg chg="del mod">
+          <ac:chgData name="Eric Huang" userId="3b01fa70-91e3-4d29-852b-56bc423b811b" providerId="ADAL" clId="{2BF4BDDA-F1A4-44EE-95EA-21AFC6EDF82F}" dt="2026-09-21T16:36:31.651" v="2737" actId="478"/>
+          <ac:cxnSpMkLst>
+            <pc:docMk/>
+            <pc:sldMk cId="3455594871" sldId="426"/>
+            <ac:cxnSpMk id="20" creationId="{C99CE3C5-FE5E-DBAF-4109-188E9BD3834F}"/>
+          </ac:cxnSpMkLst>
+        </pc:cxnChg>
+        <pc:cxnChg chg="del mod">
+          <ac:chgData name="Eric Huang" userId="3b01fa70-91e3-4d29-852b-56bc423b811b" providerId="ADAL" clId="{2BF4BDDA-F1A4-44EE-95EA-21AFC6EDF82F}" dt="2026-09-21T16:36:33.193" v="2738" actId="478"/>
+          <ac:cxnSpMkLst>
+            <pc:docMk/>
+            <pc:sldMk cId="3455594871" sldId="426"/>
+            <ac:cxnSpMk id="21" creationId="{EEB9F856-CA06-3228-1784-DDDCF0572AFE}"/>
+          </ac:cxnSpMkLst>
+        </pc:cxnChg>
+        <pc:cxnChg chg="add del mod">
+          <ac:chgData name="Eric Huang" userId="3b01fa70-91e3-4d29-852b-56bc423b811b" providerId="ADAL" clId="{2BF4BDDA-F1A4-44EE-95EA-21AFC6EDF82F}" dt="2026-09-21T16:36:48.903" v="2742" actId="478"/>
+          <ac:cxnSpMkLst>
+            <pc:docMk/>
+            <pc:sldMk cId="3455594871" sldId="426"/>
+            <ac:cxnSpMk id="25" creationId="{CFB59B28-BAA2-0C59-5C00-264AE04882BB}"/>
+          </ac:cxnSpMkLst>
+        </pc:cxnChg>
       </pc:sldChg>
     </pc:docChg>
   </pc:docChgLst>
@@ -1355,7 +1596,7 @@
           <a:p>
             <a:fld id="{DACBD60B-517C-4242-AE46-E1BD2D086542}" type="slidenum">
               <a:rPr lang="fr-FR" smtClean="0"/>
-              <a:t>38</a:t>
+              <a:t>39</a:t>
             </a:fld>
             <a:endParaRPr lang="fr-FR"/>
           </a:p>
@@ -1461,7 +1702,7 @@
           <a:p>
             <a:fld id="{DACBD60B-517C-4242-AE46-E1BD2D086542}" type="slidenum">
               <a:rPr lang="fr-FR" smtClean="0"/>
-              <a:t>42</a:t>
+              <a:t>43</a:t>
             </a:fld>
             <a:endParaRPr lang="fr-FR"/>
           </a:p>
@@ -1548,7 +1789,7 @@
           <a:p>
             <a:fld id="{DACBD60B-517C-4242-AE46-E1BD2D086542}" type="slidenum">
               <a:rPr lang="fr-FR" smtClean="0"/>
-              <a:t>45</a:t>
+              <a:t>46</a:t>
             </a:fld>
             <a:endParaRPr lang="fr-FR"/>
           </a:p>
@@ -1662,7 +1903,7 @@
           <a:p>
             <a:fld id="{DACBD60B-517C-4242-AE46-E1BD2D086542}" type="slidenum">
               <a:rPr lang="fr-FR" smtClean="0"/>
-              <a:t>48</a:t>
+              <a:t>49</a:t>
             </a:fld>
             <a:endParaRPr lang="fr-FR"/>
           </a:p>
@@ -1866,7 +2107,7 @@
           <a:p>
             <a:fld id="{DACBD60B-517C-4242-AE46-E1BD2D086542}" type="slidenum">
               <a:rPr lang="fr-FR" smtClean="0"/>
-              <a:t>49</a:t>
+              <a:t>50</a:t>
             </a:fld>
             <a:endParaRPr lang="fr-FR"/>
           </a:p>
@@ -1980,7 +2221,7 @@
           <a:p>
             <a:fld id="{DACBD60B-517C-4242-AE46-E1BD2D086542}" type="slidenum">
               <a:rPr lang="fr-FR" smtClean="0"/>
-              <a:t>55</a:t>
+              <a:t>56</a:t>
             </a:fld>
             <a:endParaRPr lang="fr-FR"/>
           </a:p>
@@ -2068,7 +2309,7 @@
           <a:p>
             <a:fld id="{DACBD60B-517C-4242-AE46-E1BD2D086542}" type="slidenum">
               <a:rPr lang="fr-FR" smtClean="0"/>
-              <a:t>60</a:t>
+              <a:t>61</a:t>
             </a:fld>
             <a:endParaRPr lang="fr-FR"/>
           </a:p>
@@ -2182,7 +2423,7 @@
           <a:p>
             <a:fld id="{DACBD60B-517C-4242-AE46-E1BD2D086542}" type="slidenum">
               <a:rPr lang="fr-FR" smtClean="0"/>
-              <a:t>63</a:t>
+              <a:t>64</a:t>
             </a:fld>
             <a:endParaRPr lang="fr-FR"/>
           </a:p>
@@ -2288,7 +2529,7 @@
           <a:p>
             <a:fld id="{DACBD60B-517C-4242-AE46-E1BD2D086542}" type="slidenum">
               <a:rPr lang="fr-FR" smtClean="0"/>
-              <a:t>66</a:t>
+              <a:t>67</a:t>
             </a:fld>
             <a:endParaRPr lang="fr-FR"/>
           </a:p>
@@ -16820,7 +17061,7 @@
         </p:nvSpPr>
         <p:spPr>
           <a:xfrm>
-            <a:off x="3128971" y="4877518"/>
+            <a:off x="3128971" y="4963778"/>
             <a:ext cx="1214089" cy="839966"/>
           </a:xfrm>
           <a:prstGeom prst="rect">
@@ -16858,12 +17099,450 @@
           </a:p>
         </p:txBody>
       </p:sp>
+    </p:spTree>
+    <p:extLst>
+      <p:ext uri="{BB962C8B-B14F-4D97-AF65-F5344CB8AC3E}">
+        <p14:creationId xmlns:p14="http://schemas.microsoft.com/office/powerpoint/2010/main" val="2209846115"/>
+      </p:ext>
+    </p:extLst>
+  </p:cSld>
+  <p:clrMapOvr>
+    <a:masterClrMapping/>
+  </p:clrMapOvr>
+</p:sld>
+</file>
+
+<file path=ppt/slides/slide37.xml><?xml version="1.0" encoding="utf-8"?>
+<p:sld xmlns:a="http://schemas.openxmlformats.org/drawingml/2006/main" xmlns:r="http://schemas.openxmlformats.org/officeDocument/2006/relationships" xmlns:p="http://schemas.openxmlformats.org/presentationml/2006/main">
+  <p:cSld>
+    <p:spTree>
+      <p:nvGrpSpPr>
+        <p:cNvPr id="1" name="">
+          <a:extLst>
+            <a:ext uri="{FF2B5EF4-FFF2-40B4-BE49-F238E27FC236}">
+              <a16:creationId xmlns:a16="http://schemas.microsoft.com/office/drawing/2014/main" id="{71B12DFF-803A-ED04-ECCF-D93CB52FD004}"/>
+            </a:ext>
+          </a:extLst>
+        </p:cNvPr>
+        <p:cNvGrpSpPr/>
+        <p:nvPr/>
+      </p:nvGrpSpPr>
+      <p:grpSpPr>
+        <a:xfrm>
+          <a:off x="0" y="0"/>
+          <a:ext cx="0" cy="0"/>
+          <a:chOff x="0" y="0"/>
+          <a:chExt cx="0" cy="0"/>
+        </a:xfrm>
+      </p:grpSpPr>
+      <p:sp>
+        <p:nvSpPr>
+          <p:cNvPr id="2" name="Text Placeholder 1">
+            <a:extLst>
+              <a:ext uri="{FF2B5EF4-FFF2-40B4-BE49-F238E27FC236}">
+                <a16:creationId xmlns:a16="http://schemas.microsoft.com/office/drawing/2014/main" id="{44BE98F5-2BE2-AF8A-1FA0-77363CE4420D}"/>
+              </a:ext>
+            </a:extLst>
+          </p:cNvPr>
+          <p:cNvSpPr>
+            <a:spLocks noGrp="1"/>
+          </p:cNvSpPr>
+          <p:nvPr>
+            <p:ph type="body" sz="quarter" idx="10"/>
+          </p:nvPr>
+        </p:nvSpPr>
+        <p:spPr/>
+        <p:txBody>
+          <a:bodyPr/>
+          <a:lstStyle/>
+          <a:p>
+            <a:pPr marL="0" indent="0">
+              <a:buNone/>
+            </a:pPr>
+            <a:r>
+              <a:rPr lang="en-CA" b="1" dirty="0"/>
+              <a:t>Rebasing</a:t>
+            </a:r>
+          </a:p>
+          <a:p>
+            <a:pPr marL="0" indent="0">
+              <a:buNone/>
+            </a:pPr>
+            <a:r>
+              <a:rPr lang="en-CA" dirty="0"/>
+              <a:t>Rewrites the target branch’s commit history to add other commits directly</a:t>
+            </a:r>
+          </a:p>
+          <a:p>
+            <a:pPr marL="0" indent="0">
+              <a:buNone/>
+            </a:pPr>
+            <a:r>
+              <a:rPr lang="en-CA" dirty="0"/>
+              <a:t>Useful for updating dev branches with new main</a:t>
+            </a:r>
+          </a:p>
+        </p:txBody>
+      </p:sp>
+      <p:sp>
+        <p:nvSpPr>
+          <p:cNvPr id="3" name="Rectangle 2">
+            <a:extLst>
+              <a:ext uri="{FF2B5EF4-FFF2-40B4-BE49-F238E27FC236}">
+                <a16:creationId xmlns:a16="http://schemas.microsoft.com/office/drawing/2014/main" id="{CC12D62F-35B0-ACBE-4363-CA2C1041120E}"/>
+              </a:ext>
+            </a:extLst>
+          </p:cNvPr>
+          <p:cNvSpPr/>
+          <p:nvPr/>
+        </p:nvSpPr>
+        <p:spPr>
+          <a:xfrm>
+            <a:off x="1424026" y="4979119"/>
+            <a:ext cx="1214089" cy="839966"/>
+          </a:xfrm>
+          <a:prstGeom prst="rect">
+            <a:avLst/>
+          </a:prstGeom>
+          <a:solidFill>
+            <a:schemeClr val="accent2"/>
+          </a:solidFill>
+        </p:spPr>
+        <p:style>
+          <a:lnRef idx="2">
+            <a:schemeClr val="accent1">
+              <a:shade val="50000"/>
+            </a:schemeClr>
+          </a:lnRef>
+          <a:fillRef idx="1">
+            <a:schemeClr val="accent1"/>
+          </a:fillRef>
+          <a:effectRef idx="0">
+            <a:schemeClr val="accent1"/>
+          </a:effectRef>
+          <a:fontRef idx="minor">
+            <a:schemeClr val="lt1"/>
+          </a:fontRef>
+        </p:style>
+        <p:txBody>
+          <a:bodyPr rtlCol="0" anchor="ctr"/>
+          <a:lstStyle/>
+          <a:p>
+            <a:pPr algn="ctr"/>
+            <a:r>
+              <a:rPr lang="en-CA" dirty="0"/>
+              <a:t>Release 1.0.0</a:t>
+            </a:r>
+          </a:p>
+        </p:txBody>
+      </p:sp>
+      <p:sp>
+        <p:nvSpPr>
+          <p:cNvPr id="4" name="Rectangle 3">
+            <a:extLst>
+              <a:ext uri="{FF2B5EF4-FFF2-40B4-BE49-F238E27FC236}">
+                <a16:creationId xmlns:a16="http://schemas.microsoft.com/office/drawing/2014/main" id="{A42DBF82-F560-3A67-AC19-919EEA1318F5}"/>
+              </a:ext>
+            </a:extLst>
+          </p:cNvPr>
+          <p:cNvSpPr/>
+          <p:nvPr/>
+        </p:nvSpPr>
+        <p:spPr>
+          <a:xfrm>
+            <a:off x="4738016" y="3519774"/>
+            <a:ext cx="1214089" cy="839966"/>
+          </a:xfrm>
+          <a:prstGeom prst="rect">
+            <a:avLst/>
+          </a:prstGeom>
+          <a:solidFill>
+            <a:schemeClr val="accent2"/>
+          </a:solidFill>
+        </p:spPr>
+        <p:style>
+          <a:lnRef idx="2">
+            <a:schemeClr val="accent1">
+              <a:shade val="50000"/>
+            </a:schemeClr>
+          </a:lnRef>
+          <a:fillRef idx="1">
+            <a:schemeClr val="accent1"/>
+          </a:fillRef>
+          <a:effectRef idx="0">
+            <a:schemeClr val="accent1"/>
+          </a:effectRef>
+          <a:fontRef idx="minor">
+            <a:schemeClr val="lt1"/>
+          </a:fontRef>
+        </p:style>
+        <p:txBody>
+          <a:bodyPr rtlCol="0" anchor="ctr"/>
+          <a:lstStyle/>
+          <a:p>
+            <a:pPr algn="ctr"/>
+            <a:r>
+              <a:rPr lang="en-CA" dirty="0"/>
+              <a:t>New Feature</a:t>
+            </a:r>
+          </a:p>
+        </p:txBody>
+      </p:sp>
+      <p:sp>
+        <p:nvSpPr>
+          <p:cNvPr id="5" name="TextBox 4">
+            <a:extLst>
+              <a:ext uri="{FF2B5EF4-FFF2-40B4-BE49-F238E27FC236}">
+                <a16:creationId xmlns:a16="http://schemas.microsoft.com/office/drawing/2014/main" id="{FC2B406A-1EDB-EB5B-2420-D9BDD6C173FD}"/>
+              </a:ext>
+            </a:extLst>
+          </p:cNvPr>
+          <p:cNvSpPr txBox="1"/>
+          <p:nvPr/>
+        </p:nvSpPr>
+        <p:spPr>
+          <a:xfrm>
+            <a:off x="290448" y="5214370"/>
+            <a:ext cx="934472" cy="369460"/>
+          </a:xfrm>
+          <a:prstGeom prst="rect">
+            <a:avLst/>
+          </a:prstGeom>
+          <a:noFill/>
+        </p:spPr>
+        <p:txBody>
+          <a:bodyPr wrap="square" rtlCol="0">
+            <a:spAutoFit/>
+          </a:bodyPr>
+          <a:lstStyle/>
+          <a:p>
+            <a:r>
+              <a:rPr lang="en-CA" b="1" dirty="0"/>
+              <a:t>Main</a:t>
+            </a:r>
+          </a:p>
+        </p:txBody>
+      </p:sp>
+      <p:cxnSp>
+        <p:nvCxnSpPr>
+          <p:cNvPr id="6" name="Connector: Elbow 5">
+            <a:extLst>
+              <a:ext uri="{FF2B5EF4-FFF2-40B4-BE49-F238E27FC236}">
+                <a16:creationId xmlns:a16="http://schemas.microsoft.com/office/drawing/2014/main" id="{B8C19822-3CFA-2A95-AF98-44B5E9AEAF7F}"/>
+              </a:ext>
+            </a:extLst>
+          </p:cNvPr>
+          <p:cNvCxnSpPr>
+            <a:cxnSpLocks/>
+            <a:endCxn id="4" idx="1"/>
+          </p:cNvCxnSpPr>
+          <p:nvPr/>
+        </p:nvCxnSpPr>
+        <p:spPr>
+          <a:xfrm rot="5400000" flipH="1" flipV="1">
+            <a:off x="3717335" y="3958438"/>
+            <a:ext cx="1039362" cy="1002000"/>
+          </a:xfrm>
+          <a:prstGeom prst="bentConnector2">
+            <a:avLst/>
+          </a:prstGeom>
+          <a:ln>
+            <a:tailEnd type="triangle"/>
+          </a:ln>
+        </p:spPr>
+        <p:style>
+          <a:lnRef idx="1">
+            <a:schemeClr val="accent1"/>
+          </a:lnRef>
+          <a:fillRef idx="0">
+            <a:schemeClr val="accent1"/>
+          </a:fillRef>
+          <a:effectRef idx="0">
+            <a:schemeClr val="accent1"/>
+          </a:effectRef>
+          <a:fontRef idx="minor">
+            <a:schemeClr val="tx1"/>
+          </a:fontRef>
+        </p:style>
+      </p:cxnSp>
+      <p:sp>
+        <p:nvSpPr>
+          <p:cNvPr id="7" name="TextBox 6">
+            <a:extLst>
+              <a:ext uri="{FF2B5EF4-FFF2-40B4-BE49-F238E27FC236}">
+                <a16:creationId xmlns:a16="http://schemas.microsoft.com/office/drawing/2014/main" id="{6701D369-EBCF-1CC5-53E6-09FFD70BB761}"/>
+              </a:ext>
+            </a:extLst>
+          </p:cNvPr>
+          <p:cNvSpPr txBox="1"/>
+          <p:nvPr/>
+        </p:nvSpPr>
+        <p:spPr>
+          <a:xfrm>
+            <a:off x="1176845" y="3755027"/>
+            <a:ext cx="934472" cy="369460"/>
+          </a:xfrm>
+          <a:prstGeom prst="rect">
+            <a:avLst/>
+          </a:prstGeom>
+          <a:noFill/>
+        </p:spPr>
+        <p:txBody>
+          <a:bodyPr wrap="square" rtlCol="0">
+            <a:spAutoFit/>
+          </a:bodyPr>
+          <a:lstStyle/>
+          <a:p>
+            <a:r>
+              <a:rPr lang="en-CA" b="1" dirty="0"/>
+              <a:t>Dev</a:t>
+            </a:r>
+          </a:p>
+        </p:txBody>
+      </p:sp>
+      <p:sp>
+        <p:nvSpPr>
+          <p:cNvPr id="8" name="Rectangle 7">
+            <a:extLst>
+              <a:ext uri="{FF2B5EF4-FFF2-40B4-BE49-F238E27FC236}">
+                <a16:creationId xmlns:a16="http://schemas.microsoft.com/office/drawing/2014/main" id="{39B98A08-4295-110D-53BF-291B26A9D413}"/>
+              </a:ext>
+            </a:extLst>
+          </p:cNvPr>
+          <p:cNvSpPr/>
+          <p:nvPr/>
+        </p:nvSpPr>
+        <p:spPr>
+          <a:xfrm>
+            <a:off x="6425497" y="3519773"/>
+            <a:ext cx="1214089" cy="839966"/>
+          </a:xfrm>
+          <a:prstGeom prst="rect">
+            <a:avLst/>
+          </a:prstGeom>
+          <a:solidFill>
+            <a:schemeClr val="accent2"/>
+          </a:solidFill>
+        </p:spPr>
+        <p:style>
+          <a:lnRef idx="2">
+            <a:schemeClr val="accent1">
+              <a:shade val="50000"/>
+            </a:schemeClr>
+          </a:lnRef>
+          <a:fillRef idx="1">
+            <a:schemeClr val="accent1"/>
+          </a:fillRef>
+          <a:effectRef idx="0">
+            <a:schemeClr val="accent1"/>
+          </a:effectRef>
+          <a:fontRef idx="minor">
+            <a:schemeClr val="lt1"/>
+          </a:fontRef>
+        </p:style>
+        <p:txBody>
+          <a:bodyPr rtlCol="0" anchor="ctr"/>
+          <a:lstStyle/>
+          <a:p>
+            <a:pPr algn="ctr"/>
+            <a:r>
+              <a:rPr lang="en-CA" dirty="0"/>
+              <a:t>Debugged New Feature</a:t>
+            </a:r>
+          </a:p>
+        </p:txBody>
+      </p:sp>
+      <p:cxnSp>
+        <p:nvCxnSpPr>
+          <p:cNvPr id="9" name="Straight Arrow Connector 8">
+            <a:extLst>
+              <a:ext uri="{FF2B5EF4-FFF2-40B4-BE49-F238E27FC236}">
+                <a16:creationId xmlns:a16="http://schemas.microsoft.com/office/drawing/2014/main" id="{DAA18DB6-BE3A-D1ED-5546-C7212C0536DA}"/>
+              </a:ext>
+            </a:extLst>
+          </p:cNvPr>
+          <p:cNvCxnSpPr>
+            <a:cxnSpLocks/>
+            <a:stCxn id="3" idx="3"/>
+          </p:cNvCxnSpPr>
+          <p:nvPr/>
+        </p:nvCxnSpPr>
+        <p:spPr>
+          <a:xfrm flipV="1">
+            <a:off x="2638115" y="5399101"/>
+            <a:ext cx="490856" cy="1"/>
+          </a:xfrm>
+          <a:prstGeom prst="straightConnector1">
+            <a:avLst/>
+          </a:prstGeom>
+          <a:ln>
+            <a:tailEnd type="triangle"/>
+          </a:ln>
+        </p:spPr>
+        <p:style>
+          <a:lnRef idx="1">
+            <a:schemeClr val="accent1"/>
+          </a:lnRef>
+          <a:fillRef idx="0">
+            <a:schemeClr val="accent1"/>
+          </a:fillRef>
+          <a:effectRef idx="0">
+            <a:schemeClr val="accent1"/>
+          </a:effectRef>
+          <a:fontRef idx="minor">
+            <a:schemeClr val="tx1"/>
+          </a:fontRef>
+        </p:style>
+      </p:cxnSp>
+      <p:cxnSp>
+        <p:nvCxnSpPr>
+          <p:cNvPr id="10" name="Straight Arrow Connector 9">
+            <a:extLst>
+              <a:ext uri="{FF2B5EF4-FFF2-40B4-BE49-F238E27FC236}">
+                <a16:creationId xmlns:a16="http://schemas.microsoft.com/office/drawing/2014/main" id="{29313149-C444-9BBA-56B4-B9E6812B1D16}"/>
+              </a:ext>
+            </a:extLst>
+          </p:cNvPr>
+          <p:cNvCxnSpPr>
+            <a:cxnSpLocks/>
+            <a:stCxn id="4" idx="3"/>
+            <a:endCxn id="8" idx="1"/>
+          </p:cNvCxnSpPr>
+          <p:nvPr/>
+        </p:nvCxnSpPr>
+        <p:spPr>
+          <a:xfrm flipV="1">
+            <a:off x="5952105" y="3939756"/>
+            <a:ext cx="473392" cy="1"/>
+          </a:xfrm>
+          <a:prstGeom prst="straightConnector1">
+            <a:avLst/>
+          </a:prstGeom>
+          <a:ln>
+            <a:tailEnd type="triangle"/>
+          </a:ln>
+        </p:spPr>
+        <p:style>
+          <a:lnRef idx="1">
+            <a:schemeClr val="accent1"/>
+          </a:lnRef>
+          <a:fillRef idx="0">
+            <a:schemeClr val="accent1"/>
+          </a:fillRef>
+          <a:effectRef idx="0">
+            <a:schemeClr val="accent1"/>
+          </a:effectRef>
+          <a:fontRef idx="minor">
+            <a:schemeClr val="tx1"/>
+          </a:fontRef>
+        </p:style>
+      </p:cxnSp>
       <p:sp>
         <p:nvSpPr>
           <p:cNvPr id="18" name="Rectangle 17">
             <a:extLst>
               <a:ext uri="{FF2B5EF4-FFF2-40B4-BE49-F238E27FC236}">
-                <a16:creationId xmlns:a16="http://schemas.microsoft.com/office/drawing/2014/main" id="{1613281B-8113-9487-9C79-9DF26C91CB96}"/>
+                <a16:creationId xmlns:a16="http://schemas.microsoft.com/office/drawing/2014/main" id="{BE15A547-BACE-EAB5-BCD2-51764D129DF7}"/>
               </a:ext>
             </a:extLst>
           </p:cNvPr>
@@ -16917,405 +17596,20 @@
           </a:p>
         </p:txBody>
       </p:sp>
-      <p:sp>
-        <p:nvSpPr>
-          <p:cNvPr id="19" name="Rectangle 18">
-            <a:extLst>
-              <a:ext uri="{FF2B5EF4-FFF2-40B4-BE49-F238E27FC236}">
-                <a16:creationId xmlns:a16="http://schemas.microsoft.com/office/drawing/2014/main" id="{F6BB5A0B-BC5C-E442-9063-B99E7446667B}"/>
-              </a:ext>
-            </a:extLst>
-          </p:cNvPr>
-          <p:cNvSpPr/>
-          <p:nvPr/>
-        </p:nvSpPr>
-        <p:spPr>
-          <a:xfrm>
-            <a:off x="4741272" y="4979117"/>
-            <a:ext cx="1214089" cy="839966"/>
-          </a:xfrm>
-          <a:prstGeom prst="rect">
-            <a:avLst/>
-          </a:prstGeom>
-          <a:solidFill>
-            <a:schemeClr val="accent2"/>
-          </a:solidFill>
-        </p:spPr>
-        <p:style>
-          <a:lnRef idx="2">
-            <a:schemeClr val="accent1">
-              <a:shade val="50000"/>
-            </a:schemeClr>
-          </a:lnRef>
-          <a:fillRef idx="1">
-            <a:schemeClr val="accent1"/>
-          </a:fillRef>
-          <a:effectRef idx="0">
-            <a:schemeClr val="accent1"/>
-          </a:effectRef>
-          <a:fontRef idx="minor">
-            <a:schemeClr val="lt1"/>
-          </a:fontRef>
-        </p:style>
-        <p:txBody>
-          <a:bodyPr rtlCol="0" anchor="ctr"/>
-          <a:lstStyle/>
-          <a:p>
-            <a:pPr algn="ctr"/>
-            <a:r>
-              <a:rPr lang="en-US" dirty="0"/>
-              <a:t>New</a:t>
-            </a:r>
-          </a:p>
-          <a:p>
-            <a:pPr algn="ctr"/>
-            <a:r>
-              <a:rPr lang="en-US" dirty="0"/>
-              <a:t>Feature</a:t>
-            </a:r>
-            <a:endParaRPr lang="en-CA" dirty="0"/>
-          </a:p>
-        </p:txBody>
-      </p:sp>
-      <p:cxnSp>
-        <p:nvCxnSpPr>
-          <p:cNvPr id="20" name="Straight Arrow Connector 19">
-            <a:extLst>
-              <a:ext uri="{FF2B5EF4-FFF2-40B4-BE49-F238E27FC236}">
-                <a16:creationId xmlns:a16="http://schemas.microsoft.com/office/drawing/2014/main" id="{9BD6F78C-8910-1110-F11E-4A9319F45E9E}"/>
-              </a:ext>
-            </a:extLst>
-          </p:cNvPr>
-          <p:cNvCxnSpPr>
-            <a:cxnSpLocks/>
-            <a:stCxn id="19" idx="3"/>
-            <a:endCxn id="28" idx="1"/>
-          </p:cNvCxnSpPr>
-          <p:nvPr/>
-        </p:nvCxnSpPr>
-        <p:spPr>
-          <a:xfrm>
-            <a:off x="5955361" y="5399100"/>
-            <a:ext cx="550524" cy="2"/>
-          </a:xfrm>
-          <a:prstGeom prst="straightConnector1">
-            <a:avLst/>
-          </a:prstGeom>
-          <a:ln>
-            <a:tailEnd type="triangle"/>
-          </a:ln>
-        </p:spPr>
-        <p:style>
-          <a:lnRef idx="1">
-            <a:schemeClr val="accent1"/>
-          </a:lnRef>
-          <a:fillRef idx="0">
-            <a:schemeClr val="accent1"/>
-          </a:fillRef>
-          <a:effectRef idx="0">
-            <a:schemeClr val="accent1"/>
-          </a:effectRef>
-          <a:fontRef idx="minor">
-            <a:schemeClr val="tx1"/>
-          </a:fontRef>
-        </p:style>
-      </p:cxnSp>
-      <p:cxnSp>
-        <p:nvCxnSpPr>
-          <p:cNvPr id="21" name="Straight Arrow Connector 20">
-            <a:extLst>
-              <a:ext uri="{FF2B5EF4-FFF2-40B4-BE49-F238E27FC236}">
-                <a16:creationId xmlns:a16="http://schemas.microsoft.com/office/drawing/2014/main" id="{AAC45847-195B-CE42-5589-B239965E542C}"/>
-              </a:ext>
-            </a:extLst>
-          </p:cNvPr>
-          <p:cNvCxnSpPr>
-            <a:cxnSpLocks/>
-            <a:endCxn id="19" idx="1"/>
-          </p:cNvCxnSpPr>
-          <p:nvPr/>
-        </p:nvCxnSpPr>
-        <p:spPr>
-          <a:xfrm flipV="1">
-            <a:off x="4343060" y="5399100"/>
-            <a:ext cx="398212" cy="1"/>
-          </a:xfrm>
-          <a:prstGeom prst="straightConnector1">
-            <a:avLst/>
-          </a:prstGeom>
-          <a:ln>
-            <a:tailEnd type="triangle"/>
-          </a:ln>
-        </p:spPr>
-        <p:style>
-          <a:lnRef idx="1">
-            <a:schemeClr val="accent1"/>
-          </a:lnRef>
-          <a:fillRef idx="0">
-            <a:schemeClr val="accent1"/>
-          </a:fillRef>
-          <a:effectRef idx="0">
-            <a:schemeClr val="accent1"/>
-          </a:effectRef>
-          <a:fontRef idx="minor">
-            <a:schemeClr val="tx1"/>
-          </a:fontRef>
-        </p:style>
-      </p:cxnSp>
-      <p:sp>
-        <p:nvSpPr>
-          <p:cNvPr id="28" name="Rectangle 27">
-            <a:extLst>
-              <a:ext uri="{FF2B5EF4-FFF2-40B4-BE49-F238E27FC236}">
-                <a16:creationId xmlns:a16="http://schemas.microsoft.com/office/drawing/2014/main" id="{4784692F-2F03-22AB-E104-B49B3B9D5442}"/>
-              </a:ext>
-            </a:extLst>
-          </p:cNvPr>
-          <p:cNvSpPr/>
-          <p:nvPr/>
-        </p:nvSpPr>
-        <p:spPr>
-          <a:xfrm>
-            <a:off x="6505885" y="4979119"/>
-            <a:ext cx="1214089" cy="839966"/>
-          </a:xfrm>
-          <a:prstGeom prst="rect">
-            <a:avLst/>
-          </a:prstGeom>
-          <a:solidFill>
-            <a:schemeClr val="accent2"/>
-          </a:solidFill>
-        </p:spPr>
-        <p:style>
-          <a:lnRef idx="2">
-            <a:schemeClr val="accent1">
-              <a:shade val="50000"/>
-            </a:schemeClr>
-          </a:lnRef>
-          <a:fillRef idx="1">
-            <a:schemeClr val="accent1"/>
-          </a:fillRef>
-          <a:effectRef idx="0">
-            <a:schemeClr val="accent1"/>
-          </a:effectRef>
-          <a:fontRef idx="minor">
-            <a:schemeClr val="lt1"/>
-          </a:fontRef>
-        </p:style>
-        <p:txBody>
-          <a:bodyPr rtlCol="0" anchor="ctr"/>
-          <a:lstStyle/>
-          <a:p>
-            <a:pPr algn="ctr"/>
-            <a:r>
-              <a:rPr lang="en-CA" dirty="0"/>
-              <a:t>Debugged New Feature</a:t>
-            </a:r>
-          </a:p>
-        </p:txBody>
-      </p:sp>
     </p:spTree>
     <p:extLst>
       <p:ext uri="{BB962C8B-B14F-4D97-AF65-F5344CB8AC3E}">
-        <p14:creationId xmlns:p14="http://schemas.microsoft.com/office/powerpoint/2010/main" val="2209846115"/>
+        <p14:creationId xmlns:p14="http://schemas.microsoft.com/office/powerpoint/2010/main" val="3455594871"/>
       </p:ext>
     </p:extLst>
   </p:cSld>
   <p:clrMapOvr>
     <a:masterClrMapping/>
   </p:clrMapOvr>
-  <p:timing>
-    <p:tnLst>
-      <p:par>
-        <p:cTn id="1" dur="indefinite" restart="never" nodeType="tmRoot">
-          <p:childTnLst>
-            <p:seq concurrent="1" nextAc="seek">
-              <p:cTn id="2" dur="indefinite" nodeType="mainSeq">
-                <p:childTnLst>
-                  <p:par>
-                    <p:cTn id="3" fill="hold">
-                      <p:stCondLst>
-                        <p:cond delay="indefinite"/>
-                      </p:stCondLst>
-                      <p:childTnLst>
-                        <p:par>
-                          <p:cTn id="4" fill="hold">
-                            <p:stCondLst>
-                              <p:cond delay="0"/>
-                            </p:stCondLst>
-                            <p:childTnLst>
-                              <p:par>
-                                <p:cTn id="5" presetID="1" presetClass="entr" presetSubtype="0" fill="hold" grpId="0" nodeType="clickEffect">
-                                  <p:stCondLst>
-                                    <p:cond delay="0"/>
-                                  </p:stCondLst>
-                                  <p:childTnLst>
-                                    <p:set>
-                                      <p:cBhvr>
-                                        <p:cTn id="6" dur="1" fill="hold">
-                                          <p:stCondLst>
-                                            <p:cond delay="0"/>
-                                          </p:stCondLst>
-                                        </p:cTn>
-                                        <p:tgtEl>
-                                          <p:spTgt spid="18"/>
-                                        </p:tgtEl>
-                                        <p:attrNameLst>
-                                          <p:attrName>style.visibility</p:attrName>
-                                        </p:attrNameLst>
-                                      </p:cBhvr>
-                                      <p:to>
-                                        <p:strVal val="visible"/>
-                                      </p:to>
-                                    </p:set>
-                                  </p:childTnLst>
-                                </p:cTn>
-                              </p:par>
-                              <p:par>
-                                <p:cTn id="7" presetID="1" presetClass="entr" presetSubtype="0" fill="hold" nodeType="withEffect">
-                                  <p:stCondLst>
-                                    <p:cond delay="0"/>
-                                  </p:stCondLst>
-                                  <p:childTnLst>
-                                    <p:set>
-                                      <p:cBhvr>
-                                        <p:cTn id="8" dur="1" fill="hold">
-                                          <p:stCondLst>
-                                            <p:cond delay="0"/>
-                                          </p:stCondLst>
-                                        </p:cTn>
-                                        <p:tgtEl>
-                                          <p:spTgt spid="21"/>
-                                        </p:tgtEl>
-                                        <p:attrNameLst>
-                                          <p:attrName>style.visibility</p:attrName>
-                                        </p:attrNameLst>
-                                      </p:cBhvr>
-                                      <p:to>
-                                        <p:strVal val="visible"/>
-                                      </p:to>
-                                    </p:set>
-                                  </p:childTnLst>
-                                </p:cTn>
-                              </p:par>
-                              <p:par>
-                                <p:cTn id="9" presetID="1" presetClass="entr" presetSubtype="0" fill="hold" grpId="0" nodeType="withEffect">
-                                  <p:stCondLst>
-                                    <p:cond delay="0"/>
-                                  </p:stCondLst>
-                                  <p:childTnLst>
-                                    <p:set>
-                                      <p:cBhvr>
-                                        <p:cTn id="10" dur="1" fill="hold">
-                                          <p:stCondLst>
-                                            <p:cond delay="0"/>
-                                          </p:stCondLst>
-                                        </p:cTn>
-                                        <p:tgtEl>
-                                          <p:spTgt spid="19"/>
-                                        </p:tgtEl>
-                                        <p:attrNameLst>
-                                          <p:attrName>style.visibility</p:attrName>
-                                        </p:attrNameLst>
-                                      </p:cBhvr>
-                                      <p:to>
-                                        <p:strVal val="visible"/>
-                                      </p:to>
-                                    </p:set>
-                                  </p:childTnLst>
-                                </p:cTn>
-                              </p:par>
-                              <p:par>
-                                <p:cTn id="11" presetID="1" presetClass="entr" presetSubtype="0" fill="hold" nodeType="withEffect">
-                                  <p:stCondLst>
-                                    <p:cond delay="0"/>
-                                  </p:stCondLst>
-                                  <p:childTnLst>
-                                    <p:set>
-                                      <p:cBhvr>
-                                        <p:cTn id="12" dur="1" fill="hold">
-                                          <p:stCondLst>
-                                            <p:cond delay="0"/>
-                                          </p:stCondLst>
-                                        </p:cTn>
-                                        <p:tgtEl>
-                                          <p:spTgt spid="20"/>
-                                        </p:tgtEl>
-                                        <p:attrNameLst>
-                                          <p:attrName>style.visibility</p:attrName>
-                                        </p:attrNameLst>
-                                      </p:cBhvr>
-                                      <p:to>
-                                        <p:strVal val="visible"/>
-                                      </p:to>
-                                    </p:set>
-                                  </p:childTnLst>
-                                </p:cTn>
-                              </p:par>
-                              <p:par>
-                                <p:cTn id="13" presetID="1" presetClass="entr" presetSubtype="0" fill="hold" grpId="0" nodeType="withEffect">
-                                  <p:stCondLst>
-                                    <p:cond delay="0"/>
-                                  </p:stCondLst>
-                                  <p:childTnLst>
-                                    <p:set>
-                                      <p:cBhvr>
-                                        <p:cTn id="14" dur="1" fill="hold">
-                                          <p:stCondLst>
-                                            <p:cond delay="0"/>
-                                          </p:stCondLst>
-                                        </p:cTn>
-                                        <p:tgtEl>
-                                          <p:spTgt spid="28"/>
-                                        </p:tgtEl>
-                                        <p:attrNameLst>
-                                          <p:attrName>style.visibility</p:attrName>
-                                        </p:attrNameLst>
-                                      </p:cBhvr>
-                                      <p:to>
-                                        <p:strVal val="visible"/>
-                                      </p:to>
-                                    </p:set>
-                                  </p:childTnLst>
-                                </p:cTn>
-                              </p:par>
-                            </p:childTnLst>
-                          </p:cTn>
-                        </p:par>
-                      </p:childTnLst>
-                    </p:cTn>
-                  </p:par>
-                </p:childTnLst>
-              </p:cTn>
-              <p:prevCondLst>
-                <p:cond evt="onPrev" delay="0">
-                  <p:tgtEl>
-                    <p:sldTgt/>
-                  </p:tgtEl>
-                </p:cond>
-              </p:prevCondLst>
-              <p:nextCondLst>
-                <p:cond evt="onNext" delay="0">
-                  <p:tgtEl>
-                    <p:sldTgt/>
-                  </p:tgtEl>
-                </p:cond>
-              </p:nextCondLst>
-            </p:seq>
-          </p:childTnLst>
-        </p:cTn>
-      </p:par>
-    </p:tnLst>
-    <p:bldLst>
-      <p:bldP spid="18" grpId="0" animBg="1"/>
-      <p:bldP spid="19" grpId="0" animBg="1"/>
-      <p:bldP spid="28" grpId="0" animBg="1"/>
-    </p:bldLst>
-  </p:timing>
 </p:sld>
 </file>
 
-<file path=ppt/slides/slide37.xml><?xml version="1.0" encoding="utf-8"?>
+<file path=ppt/slides/slide38.xml><?xml version="1.0" encoding="utf-8"?>
 <p:sld xmlns:a="http://schemas.openxmlformats.org/drawingml/2006/main" xmlns:r="http://schemas.openxmlformats.org/officeDocument/2006/relationships" xmlns:p="http://schemas.openxmlformats.org/presentationml/2006/main">
   <p:cSld>
     <p:spTree>
@@ -17406,7 +17700,7 @@
 </p:sld>
 </file>
 
-<file path=ppt/slides/slide38.xml><?xml version="1.0" encoding="utf-8"?>
+<file path=ppt/slides/slide39.xml><?xml version="1.0" encoding="utf-8"?>
 <p:sld xmlns:a="http://schemas.openxmlformats.org/drawingml/2006/main" xmlns:r="http://schemas.openxmlformats.org/officeDocument/2006/relationships" xmlns:p="http://schemas.openxmlformats.org/presentationml/2006/main">
   <p:cSld>
     <p:spTree>
@@ -17744,7 +18038,107 @@
 </p:sld>
 </file>
 
-<file path=ppt/slides/slide39.xml><?xml version="1.0" encoding="utf-8"?>
+<file path=ppt/slides/slide4.xml><?xml version="1.0" encoding="utf-8"?>
+<p:sld xmlns:a="http://schemas.openxmlformats.org/drawingml/2006/main" xmlns:r="http://schemas.openxmlformats.org/officeDocument/2006/relationships" xmlns:p="http://schemas.openxmlformats.org/presentationml/2006/main">
+  <p:cSld>
+    <p:spTree>
+      <p:nvGrpSpPr>
+        <p:cNvPr id="1" name=""/>
+        <p:cNvGrpSpPr/>
+        <p:nvPr/>
+      </p:nvGrpSpPr>
+      <p:grpSpPr>
+        <a:xfrm>
+          <a:off x="0" y="0"/>
+          <a:ext cx="0" cy="0"/>
+          <a:chOff x="0" y="0"/>
+          <a:chExt cx="0" cy="0"/>
+        </a:xfrm>
+      </p:grpSpPr>
+      <p:sp>
+        <p:nvSpPr>
+          <p:cNvPr id="2" name="Text Placeholder 1">
+            <a:extLst>
+              <a:ext uri="{FF2B5EF4-FFF2-40B4-BE49-F238E27FC236}">
+                <a16:creationId xmlns:a16="http://schemas.microsoft.com/office/drawing/2014/main" id="{09E2662B-C95B-76DF-8523-2BDCBE3A731E}"/>
+              </a:ext>
+            </a:extLst>
+          </p:cNvPr>
+          <p:cNvSpPr>
+            <a:spLocks noGrp="1"/>
+          </p:cNvSpPr>
+          <p:nvPr>
+            <p:ph type="body" sz="quarter" idx="10"/>
+          </p:nvPr>
+        </p:nvSpPr>
+        <p:spPr/>
+        <p:txBody>
+          <a:bodyPr/>
+          <a:lstStyle/>
+          <a:p>
+            <a:pPr marL="0" indent="0">
+              <a:buNone/>
+            </a:pPr>
+            <a:r>
+              <a:rPr lang="en-CA" b="1" dirty="0"/>
+              <a:t>What you WILL learn</a:t>
+            </a:r>
+          </a:p>
+          <a:p>
+            <a:r>
+              <a:rPr lang="en-CA" dirty="0"/>
+              <a:t>Basic theory and features behind Git and GitHub</a:t>
+            </a:r>
+          </a:p>
+          <a:p>
+            <a:r>
+              <a:rPr lang="en-CA" dirty="0"/>
+              <a:t>How to manage local and remote repositories</a:t>
+            </a:r>
+          </a:p>
+          <a:p>
+            <a:pPr marL="0" indent="0">
+              <a:buNone/>
+            </a:pPr>
+            <a:endParaRPr lang="en-CA" dirty="0"/>
+          </a:p>
+          <a:p>
+            <a:pPr marL="0" indent="0">
+              <a:buNone/>
+            </a:pPr>
+            <a:r>
+              <a:rPr lang="en-CA" b="1" dirty="0"/>
+              <a:t>What you will NOT learn</a:t>
+            </a:r>
+          </a:p>
+          <a:p>
+            <a:r>
+              <a:rPr lang="en-CA" dirty="0"/>
+              <a:t>How to code</a:t>
+            </a:r>
+          </a:p>
+          <a:p>
+            <a:r>
+              <a:rPr lang="en-CA" dirty="0"/>
+              <a:t>Data Analysis Pipelines</a:t>
+            </a:r>
+          </a:p>
+        </p:txBody>
+      </p:sp>
+    </p:spTree>
+    <p:extLst>
+      <p:ext uri="{BB962C8B-B14F-4D97-AF65-F5344CB8AC3E}">
+        <p14:creationId xmlns:p14="http://schemas.microsoft.com/office/powerpoint/2010/main" val="2837531258"/>
+      </p:ext>
+    </p:extLst>
+  </p:cSld>
+  <p:clrMapOvr>
+    <a:masterClrMapping/>
+  </p:clrMapOvr>
+</p:sld>
+</file>
+
+<file path=ppt/slides/slide40.xml><?xml version="1.0" encoding="utf-8"?>
 <p:sld xmlns:a="http://schemas.openxmlformats.org/drawingml/2006/main" xmlns:r="http://schemas.openxmlformats.org/officeDocument/2006/relationships" xmlns:p="http://schemas.openxmlformats.org/presentationml/2006/main">
   <p:cSld>
     <p:spTree>
@@ -18034,107 +18428,7 @@
 </p:sld>
 </file>
 
-<file path=ppt/slides/slide4.xml><?xml version="1.0" encoding="utf-8"?>
-<p:sld xmlns:a="http://schemas.openxmlformats.org/drawingml/2006/main" xmlns:r="http://schemas.openxmlformats.org/officeDocument/2006/relationships" xmlns:p="http://schemas.openxmlformats.org/presentationml/2006/main">
-  <p:cSld>
-    <p:spTree>
-      <p:nvGrpSpPr>
-        <p:cNvPr id="1" name=""/>
-        <p:cNvGrpSpPr/>
-        <p:nvPr/>
-      </p:nvGrpSpPr>
-      <p:grpSpPr>
-        <a:xfrm>
-          <a:off x="0" y="0"/>
-          <a:ext cx="0" cy="0"/>
-          <a:chOff x="0" y="0"/>
-          <a:chExt cx="0" cy="0"/>
-        </a:xfrm>
-      </p:grpSpPr>
-      <p:sp>
-        <p:nvSpPr>
-          <p:cNvPr id="2" name="Text Placeholder 1">
-            <a:extLst>
-              <a:ext uri="{FF2B5EF4-FFF2-40B4-BE49-F238E27FC236}">
-                <a16:creationId xmlns:a16="http://schemas.microsoft.com/office/drawing/2014/main" id="{09E2662B-C95B-76DF-8523-2BDCBE3A731E}"/>
-              </a:ext>
-            </a:extLst>
-          </p:cNvPr>
-          <p:cNvSpPr>
-            <a:spLocks noGrp="1"/>
-          </p:cNvSpPr>
-          <p:nvPr>
-            <p:ph type="body" sz="quarter" idx="10"/>
-          </p:nvPr>
-        </p:nvSpPr>
-        <p:spPr/>
-        <p:txBody>
-          <a:bodyPr/>
-          <a:lstStyle/>
-          <a:p>
-            <a:pPr marL="0" indent="0">
-              <a:buNone/>
-            </a:pPr>
-            <a:r>
-              <a:rPr lang="en-CA" b="1" dirty="0"/>
-              <a:t>What you WILL learn</a:t>
-            </a:r>
-          </a:p>
-          <a:p>
-            <a:r>
-              <a:rPr lang="en-CA" dirty="0"/>
-              <a:t>Basic theory and features behind Git and GitHub</a:t>
-            </a:r>
-          </a:p>
-          <a:p>
-            <a:r>
-              <a:rPr lang="en-CA" dirty="0"/>
-              <a:t>How to manage local and remote repositories</a:t>
-            </a:r>
-          </a:p>
-          <a:p>
-            <a:pPr marL="0" indent="0">
-              <a:buNone/>
-            </a:pPr>
-            <a:endParaRPr lang="en-CA" dirty="0"/>
-          </a:p>
-          <a:p>
-            <a:pPr marL="0" indent="0">
-              <a:buNone/>
-            </a:pPr>
-            <a:r>
-              <a:rPr lang="en-CA" b="1" dirty="0"/>
-              <a:t>What you will NOT learn</a:t>
-            </a:r>
-          </a:p>
-          <a:p>
-            <a:r>
-              <a:rPr lang="en-CA" dirty="0"/>
-              <a:t>How to code</a:t>
-            </a:r>
-          </a:p>
-          <a:p>
-            <a:r>
-              <a:rPr lang="en-CA" dirty="0"/>
-              <a:t>Data Analysis Pipelines</a:t>
-            </a:r>
-          </a:p>
-        </p:txBody>
-      </p:sp>
-    </p:spTree>
-    <p:extLst>
-      <p:ext uri="{BB962C8B-B14F-4D97-AF65-F5344CB8AC3E}">
-        <p14:creationId xmlns:p14="http://schemas.microsoft.com/office/powerpoint/2010/main" val="2837531258"/>
-      </p:ext>
-    </p:extLst>
-  </p:cSld>
-  <p:clrMapOvr>
-    <a:masterClrMapping/>
-  </p:clrMapOvr>
-</p:sld>
-</file>
-
-<file path=ppt/slides/slide40.xml><?xml version="1.0" encoding="utf-8"?>
+<file path=ppt/slides/slide41.xml><?xml version="1.0" encoding="utf-8"?>
 <p:sld xmlns:a="http://schemas.openxmlformats.org/drawingml/2006/main" xmlns:r="http://schemas.openxmlformats.org/officeDocument/2006/relationships" xmlns:p="http://schemas.openxmlformats.org/presentationml/2006/main">
   <p:cSld>
     <p:spTree>
@@ -18219,7 +18513,7 @@
 </p:sld>
 </file>
 
-<file path=ppt/slides/slide41.xml><?xml version="1.0" encoding="utf-8"?>
+<file path=ppt/slides/slide42.xml><?xml version="1.0" encoding="utf-8"?>
 <p:sld xmlns:a="http://schemas.openxmlformats.org/drawingml/2006/main" xmlns:r="http://schemas.openxmlformats.org/officeDocument/2006/relationships" xmlns:p="http://schemas.openxmlformats.org/presentationml/2006/main">
   <p:cSld>
     <p:spTree>
@@ -18646,7 +18940,7 @@
 </p:sld>
 </file>
 
-<file path=ppt/slides/slide42.xml><?xml version="1.0" encoding="utf-8"?>
+<file path=ppt/slides/slide43.xml><?xml version="1.0" encoding="utf-8"?>
 <p:sld xmlns:a="http://schemas.openxmlformats.org/drawingml/2006/main" xmlns:r="http://schemas.openxmlformats.org/officeDocument/2006/relationships" xmlns:p="http://schemas.openxmlformats.org/presentationml/2006/main">
   <p:cSld>
     <p:spTree>
@@ -18941,7 +19235,7 @@
 </p:sld>
 </file>
 
-<file path=ppt/slides/slide43.xml><?xml version="1.0" encoding="utf-8"?>
+<file path=ppt/slides/slide44.xml><?xml version="1.0" encoding="utf-8"?>
 <p:sld xmlns:a="http://schemas.openxmlformats.org/drawingml/2006/main" xmlns:r="http://schemas.openxmlformats.org/officeDocument/2006/relationships" xmlns:p="http://schemas.openxmlformats.org/presentationml/2006/main">
   <p:cSld>
     <p:spTree>
@@ -19206,7 +19500,7 @@
 </p:sld>
 </file>
 
-<file path=ppt/slides/slide44.xml><?xml version="1.0" encoding="utf-8"?>
+<file path=ppt/slides/slide45.xml><?xml version="1.0" encoding="utf-8"?>
 <p:sld xmlns:a="http://schemas.openxmlformats.org/drawingml/2006/main" xmlns:r="http://schemas.openxmlformats.org/officeDocument/2006/relationships" xmlns:p="http://schemas.openxmlformats.org/presentationml/2006/main">
   <p:cSld>
     <p:spTree>
@@ -19264,7 +19558,7 @@
 </p:sld>
 </file>
 
-<file path=ppt/slides/slide45.xml><?xml version="1.0" encoding="utf-8"?>
+<file path=ppt/slides/slide46.xml><?xml version="1.0" encoding="utf-8"?>
 <p:sld xmlns:a="http://schemas.openxmlformats.org/drawingml/2006/main" xmlns:r="http://schemas.openxmlformats.org/officeDocument/2006/relationships" xmlns:p="http://schemas.openxmlformats.org/presentationml/2006/main">
   <p:cSld>
     <p:spTree>
@@ -19322,7 +19616,7 @@
 </p:sld>
 </file>
 
-<file path=ppt/slides/slide46.xml><?xml version="1.0" encoding="utf-8"?>
+<file path=ppt/slides/slide47.xml><?xml version="1.0" encoding="utf-8"?>
 <p:sld xmlns:a="http://schemas.openxmlformats.org/drawingml/2006/main" xmlns:r="http://schemas.openxmlformats.org/officeDocument/2006/relationships" xmlns:p="http://schemas.openxmlformats.org/presentationml/2006/main">
   <p:cSld>
     <p:spTree>
@@ -19796,7 +20090,7 @@
 </p:sld>
 </file>
 
-<file path=ppt/slides/slide47.xml><?xml version="1.0" encoding="utf-8"?>
+<file path=ppt/slides/slide48.xml><?xml version="1.0" encoding="utf-8"?>
 <p:sld xmlns:a="http://schemas.openxmlformats.org/drawingml/2006/main" xmlns:r="http://schemas.openxmlformats.org/officeDocument/2006/relationships" xmlns:p="http://schemas.openxmlformats.org/presentationml/2006/main">
   <p:cSld>
     <p:spTree>
@@ -19917,7 +20211,7 @@
 </p:sld>
 </file>
 
-<file path=ppt/slides/slide48.xml><?xml version="1.0" encoding="utf-8"?>
+<file path=ppt/slides/slide49.xml><?xml version="1.0" encoding="utf-8"?>
 <p:sld xmlns:a="http://schemas.openxmlformats.org/drawingml/2006/main" xmlns:r="http://schemas.openxmlformats.org/officeDocument/2006/relationships" xmlns:p="http://schemas.openxmlformats.org/presentationml/2006/main">
   <p:cSld>
     <p:spTree>
@@ -20956,7 +21250,67 @@
 </p:sld>
 </file>
 
-<file path=ppt/slides/slide49.xml><?xml version="1.0" encoding="utf-8"?>
+<file path=ppt/slides/slide5.xml><?xml version="1.0" encoding="utf-8"?>
+<p:sld xmlns:a="http://schemas.openxmlformats.org/drawingml/2006/main" xmlns:r="http://schemas.openxmlformats.org/officeDocument/2006/relationships" xmlns:p="http://schemas.openxmlformats.org/presentationml/2006/main">
+  <p:cSld>
+    <p:spTree>
+      <p:nvGrpSpPr>
+        <p:cNvPr id="1" name=""/>
+        <p:cNvGrpSpPr/>
+        <p:nvPr/>
+      </p:nvGrpSpPr>
+      <p:grpSpPr>
+        <a:xfrm>
+          <a:off x="0" y="0"/>
+          <a:ext cx="0" cy="0"/>
+          <a:chOff x="0" y="0"/>
+          <a:chExt cx="0" cy="0"/>
+        </a:xfrm>
+      </p:grpSpPr>
+      <p:pic>
+        <p:nvPicPr>
+          <p:cNvPr id="3" name="Picture 2">
+            <a:extLst>
+              <a:ext uri="{FF2B5EF4-FFF2-40B4-BE49-F238E27FC236}">
+                <a16:creationId xmlns:a16="http://schemas.microsoft.com/office/drawing/2014/main" id="{D63D6295-D41F-B16A-80CA-1D999E04CFC6}"/>
+              </a:ext>
+            </a:extLst>
+          </p:cNvPr>
+          <p:cNvPicPr>
+            <a:picLocks noChangeAspect="1"/>
+          </p:cNvPicPr>
+          <p:nvPr/>
+        </p:nvPicPr>
+        <p:blipFill>
+          <a:blip r:embed="rId2"/>
+          <a:stretch>
+            <a:fillRect/>
+          </a:stretch>
+        </p:blipFill>
+        <p:spPr>
+          <a:xfrm>
+            <a:off x="1768849" y="1213562"/>
+            <a:ext cx="3970552" cy="5294069"/>
+          </a:xfrm>
+          <a:prstGeom prst="rect">
+            <a:avLst/>
+          </a:prstGeom>
+        </p:spPr>
+      </p:pic>
+    </p:spTree>
+    <p:extLst>
+      <p:ext uri="{BB962C8B-B14F-4D97-AF65-F5344CB8AC3E}">
+        <p14:creationId xmlns:p14="http://schemas.microsoft.com/office/powerpoint/2010/main" val="910056172"/>
+      </p:ext>
+    </p:extLst>
+  </p:cSld>
+  <p:clrMapOvr>
+    <a:masterClrMapping/>
+  </p:clrMapOvr>
+</p:sld>
+</file>
+
+<file path=ppt/slides/slide50.xml><?xml version="1.0" encoding="utf-8"?>
 <p:sld xmlns:a="http://schemas.openxmlformats.org/drawingml/2006/main" xmlns:r="http://schemas.openxmlformats.org/officeDocument/2006/relationships" xmlns:p="http://schemas.openxmlformats.org/presentationml/2006/main">
   <p:cSld>
     <p:spTree>
@@ -22057,67 +22411,7 @@
 </p:sld>
 </file>
 
-<file path=ppt/slides/slide5.xml><?xml version="1.0" encoding="utf-8"?>
-<p:sld xmlns:a="http://schemas.openxmlformats.org/drawingml/2006/main" xmlns:r="http://schemas.openxmlformats.org/officeDocument/2006/relationships" xmlns:p="http://schemas.openxmlformats.org/presentationml/2006/main">
-  <p:cSld>
-    <p:spTree>
-      <p:nvGrpSpPr>
-        <p:cNvPr id="1" name=""/>
-        <p:cNvGrpSpPr/>
-        <p:nvPr/>
-      </p:nvGrpSpPr>
-      <p:grpSpPr>
-        <a:xfrm>
-          <a:off x="0" y="0"/>
-          <a:ext cx="0" cy="0"/>
-          <a:chOff x="0" y="0"/>
-          <a:chExt cx="0" cy="0"/>
-        </a:xfrm>
-      </p:grpSpPr>
-      <p:pic>
-        <p:nvPicPr>
-          <p:cNvPr id="3" name="Picture 2">
-            <a:extLst>
-              <a:ext uri="{FF2B5EF4-FFF2-40B4-BE49-F238E27FC236}">
-                <a16:creationId xmlns:a16="http://schemas.microsoft.com/office/drawing/2014/main" id="{D63D6295-D41F-B16A-80CA-1D999E04CFC6}"/>
-              </a:ext>
-            </a:extLst>
-          </p:cNvPr>
-          <p:cNvPicPr>
-            <a:picLocks noChangeAspect="1"/>
-          </p:cNvPicPr>
-          <p:nvPr/>
-        </p:nvPicPr>
-        <p:blipFill>
-          <a:blip r:embed="rId2"/>
-          <a:stretch>
-            <a:fillRect/>
-          </a:stretch>
-        </p:blipFill>
-        <p:spPr>
-          <a:xfrm>
-            <a:off x="1768849" y="1213562"/>
-            <a:ext cx="3970552" cy="5294069"/>
-          </a:xfrm>
-          <a:prstGeom prst="rect">
-            <a:avLst/>
-          </a:prstGeom>
-        </p:spPr>
-      </p:pic>
-    </p:spTree>
-    <p:extLst>
-      <p:ext uri="{BB962C8B-B14F-4D97-AF65-F5344CB8AC3E}">
-        <p14:creationId xmlns:p14="http://schemas.microsoft.com/office/powerpoint/2010/main" val="910056172"/>
-      </p:ext>
-    </p:extLst>
-  </p:cSld>
-  <p:clrMapOvr>
-    <a:masterClrMapping/>
-  </p:clrMapOvr>
-</p:sld>
-</file>
-
-<file path=ppt/slides/slide50.xml><?xml version="1.0" encoding="utf-8"?>
+<file path=ppt/slides/slide51.xml><?xml version="1.0" encoding="utf-8"?>
 <p:sld xmlns:a="http://schemas.openxmlformats.org/drawingml/2006/main" xmlns:r="http://schemas.openxmlformats.org/officeDocument/2006/relationships" xmlns:p="http://schemas.openxmlformats.org/presentationml/2006/main">
   <p:cSld>
     <p:spTree>
@@ -22202,7 +22496,7 @@
 </p:sld>
 </file>
 
-<file path=ppt/slides/slide51.xml><?xml version="1.0" encoding="utf-8"?>
+<file path=ppt/slides/slide52.xml><?xml version="1.0" encoding="utf-8"?>
 <p:sld xmlns:a="http://schemas.openxmlformats.org/drawingml/2006/main" xmlns:r="http://schemas.openxmlformats.org/officeDocument/2006/relationships" xmlns:p="http://schemas.openxmlformats.org/presentationml/2006/main">
   <p:cSld>
     <p:spTree>
@@ -22427,7 +22721,7 @@
 </p:sld>
 </file>
 
-<file path=ppt/slides/slide52.xml><?xml version="1.0" encoding="utf-8"?>
+<file path=ppt/slides/slide53.xml><?xml version="1.0" encoding="utf-8"?>
 <p:sld xmlns:a="http://schemas.openxmlformats.org/drawingml/2006/main" xmlns:r="http://schemas.openxmlformats.org/officeDocument/2006/relationships" xmlns:p="http://schemas.openxmlformats.org/presentationml/2006/main">
   <p:cSld>
     <p:spTree>
@@ -22512,7 +22806,7 @@
 </p:sld>
 </file>
 
-<file path=ppt/slides/slide53.xml><?xml version="1.0" encoding="utf-8"?>
+<file path=ppt/slides/slide54.xml><?xml version="1.0" encoding="utf-8"?>
 <p:sld xmlns:a="http://schemas.openxmlformats.org/drawingml/2006/main" xmlns:r="http://schemas.openxmlformats.org/officeDocument/2006/relationships" xmlns:p="http://schemas.openxmlformats.org/presentationml/2006/main">
   <p:cSld>
     <p:spTree>
@@ -22863,7 +23157,7 @@
 </p:sld>
 </file>
 
-<file path=ppt/slides/slide54.xml><?xml version="1.0" encoding="utf-8"?>
+<file path=ppt/slides/slide55.xml><?xml version="1.0" encoding="utf-8"?>
 <p:sld xmlns:a="http://schemas.openxmlformats.org/drawingml/2006/main" xmlns:r="http://schemas.openxmlformats.org/officeDocument/2006/relationships" xmlns:p="http://schemas.openxmlformats.org/presentationml/2006/main">
   <p:cSld>
     <p:spTree>
@@ -23028,7 +23322,7 @@
 </p:sld>
 </file>
 
-<file path=ppt/slides/slide55.xml><?xml version="1.0" encoding="utf-8"?>
+<file path=ppt/slides/slide56.xml><?xml version="1.0" encoding="utf-8"?>
 <p:sld xmlns:a="http://schemas.openxmlformats.org/drawingml/2006/main" xmlns:r="http://schemas.openxmlformats.org/officeDocument/2006/relationships" xmlns:p="http://schemas.openxmlformats.org/presentationml/2006/main">
   <p:cSld>
     <p:spTree>
@@ -23842,7 +24136,7 @@
 </p:sld>
 </file>
 
-<file path=ppt/slides/slide56.xml><?xml version="1.0" encoding="utf-8"?>
+<file path=ppt/slides/slide57.xml><?xml version="1.0" encoding="utf-8"?>
 <p:sld xmlns:a="http://schemas.openxmlformats.org/drawingml/2006/main" xmlns:r="http://schemas.openxmlformats.org/officeDocument/2006/relationships" xmlns:p="http://schemas.openxmlformats.org/presentationml/2006/main">
   <p:cSld>
     <p:spTree>
@@ -23936,7 +24230,7 @@
 </p:sld>
 </file>
 
-<file path=ppt/slides/slide57.xml><?xml version="1.0" encoding="utf-8"?>
+<file path=ppt/slides/slide58.xml><?xml version="1.0" encoding="utf-8"?>
 <p:sld xmlns:a="http://schemas.openxmlformats.org/drawingml/2006/main" xmlns:r="http://schemas.openxmlformats.org/officeDocument/2006/relationships" xmlns:p="http://schemas.openxmlformats.org/presentationml/2006/main">
   <p:cSld>
     <p:spTree>
@@ -24325,7 +24619,7 @@
 </p:sld>
 </file>
 
-<file path=ppt/slides/slide58.xml><?xml version="1.0" encoding="utf-8"?>
+<file path=ppt/slides/slide59.xml><?xml version="1.0" encoding="utf-8"?>
 <p:sld xmlns:a="http://schemas.openxmlformats.org/drawingml/2006/main" xmlns:r="http://schemas.openxmlformats.org/officeDocument/2006/relationships" xmlns:p="http://schemas.openxmlformats.org/presentationml/2006/main">
   <p:cSld>
     <p:spTree>
@@ -24374,7 +24668,7 @@
             </a:pPr>
             <a:r>
               <a:rPr lang="en-CA" b="1" dirty="0"/>
-              <a:t>Contributing to a Shared Repo</a:t>
+              <a:t>Contributing to shared projects</a:t>
             </a:r>
           </a:p>
           <a:p>
@@ -24551,111 +24845,6 @@
 </p:sld>
 </file>
 
-<file path=ppt/slides/slide59.xml><?xml version="1.0" encoding="utf-8"?>
-<p:sld xmlns:a="http://schemas.openxmlformats.org/drawingml/2006/main" xmlns:r="http://schemas.openxmlformats.org/officeDocument/2006/relationships" xmlns:p="http://schemas.openxmlformats.org/presentationml/2006/main">
-  <p:cSld>
-    <p:spTree>
-      <p:nvGrpSpPr>
-        <p:cNvPr id="1" name="">
-          <a:extLst>
-            <a:ext uri="{FF2B5EF4-FFF2-40B4-BE49-F238E27FC236}">
-              <a16:creationId xmlns:a16="http://schemas.microsoft.com/office/drawing/2014/main" id="{F368447F-C531-92C9-0376-B1178B60E7A4}"/>
-            </a:ext>
-          </a:extLst>
-        </p:cNvPr>
-        <p:cNvGrpSpPr/>
-        <p:nvPr/>
-      </p:nvGrpSpPr>
-      <p:grpSpPr>
-        <a:xfrm>
-          <a:off x="0" y="0"/>
-          <a:ext cx="0" cy="0"/>
-          <a:chOff x="0" y="0"/>
-          <a:chExt cx="0" cy="0"/>
-        </a:xfrm>
-      </p:grpSpPr>
-      <p:sp>
-        <p:nvSpPr>
-          <p:cNvPr id="2" name="Text Placeholder 1">
-            <a:extLst>
-              <a:ext uri="{FF2B5EF4-FFF2-40B4-BE49-F238E27FC236}">
-                <a16:creationId xmlns:a16="http://schemas.microsoft.com/office/drawing/2014/main" id="{47F55FDA-5B7A-0A15-4B0E-B0E183049B90}"/>
-              </a:ext>
-            </a:extLst>
-          </p:cNvPr>
-          <p:cNvSpPr>
-            <a:spLocks noGrp="1"/>
-          </p:cNvSpPr>
-          <p:nvPr>
-            <p:ph type="body" sz="quarter" idx="10"/>
-          </p:nvPr>
-        </p:nvSpPr>
-        <p:spPr/>
-        <p:txBody>
-          <a:bodyPr/>
-          <a:lstStyle/>
-          <a:p>
-            <a:pPr marL="0" indent="0">
-              <a:buNone/>
-            </a:pPr>
-            <a:endParaRPr lang="en-CA" b="1" dirty="0"/>
-          </a:p>
-          <a:p>
-            <a:pPr marL="0" indent="0">
-              <a:buNone/>
-            </a:pPr>
-            <a:endParaRPr lang="en-CA" b="1" dirty="0"/>
-          </a:p>
-          <a:p>
-            <a:pPr marL="0" indent="0">
-              <a:buNone/>
-            </a:pPr>
-            <a:endParaRPr lang="en-CA" b="1" dirty="0"/>
-          </a:p>
-          <a:p>
-            <a:pPr marL="0" indent="0">
-              <a:buNone/>
-            </a:pPr>
-            <a:endParaRPr lang="en-CA" b="1" dirty="0"/>
-          </a:p>
-          <a:p>
-            <a:pPr marL="0" indent="0">
-              <a:buNone/>
-            </a:pPr>
-            <a:r>
-              <a:rPr lang="en-CA" b="1" dirty="0"/>
-              <a:t>Activity #9.1 – Contribute to a shared repo</a:t>
-            </a:r>
-          </a:p>
-          <a:p>
-            <a:pPr marL="0" indent="0">
-              <a:buNone/>
-            </a:pPr>
-            <a:r>
-              <a:rPr lang="en-CA" b="1" dirty="0"/>
-              <a:t>- </a:t>
-            </a:r>
-            <a:r>
-              <a:rPr lang="en-CA" dirty="0"/>
-              <a:t>Work in teams to contribute to a shared repository</a:t>
-            </a:r>
-            <a:endParaRPr lang="en-CA" b="1" dirty="0"/>
-          </a:p>
-        </p:txBody>
-      </p:sp>
-    </p:spTree>
-    <p:extLst>
-      <p:ext uri="{BB962C8B-B14F-4D97-AF65-F5344CB8AC3E}">
-        <p14:creationId xmlns:p14="http://schemas.microsoft.com/office/powerpoint/2010/main" val="3592577252"/>
-      </p:ext>
-    </p:extLst>
-  </p:cSld>
-  <p:clrMapOvr>
-    <a:masterClrMapping/>
-  </p:clrMapOvr>
-</p:sld>
-</file>
-
 <file path=ppt/slides/slide6.xml><?xml version="1.0" encoding="utf-8"?>
 <p:sld xmlns:a="http://schemas.openxmlformats.org/drawingml/2006/main" xmlns:r="http://schemas.openxmlformats.org/officeDocument/2006/relationships" xmlns:p="http://schemas.openxmlformats.org/presentationml/2006/main">
   <p:cSld>
@@ -24805,7 +24994,112 @@
 </file>
 
 <file path=ppt/slides/slide60.xml><?xml version="1.0" encoding="utf-8"?>
-<p:sld xmlns:a="http://schemas.openxmlformats.org/drawingml/2006/main" xmlns:r="http://schemas.openxmlformats.org/officeDocument/2006/relationships" xmlns:p="http://schemas.openxmlformats.org/presentationml/2006/main">
+<p:sld xmlns:a="http://schemas.openxmlformats.org/drawingml/2006/main" xmlns:r="http://schemas.openxmlformats.org/officeDocument/2006/relationships" xmlns:p="http://schemas.openxmlformats.org/presentationml/2006/main" show="0">
+  <p:cSld>
+    <p:spTree>
+      <p:nvGrpSpPr>
+        <p:cNvPr id="1" name="">
+          <a:extLst>
+            <a:ext uri="{FF2B5EF4-FFF2-40B4-BE49-F238E27FC236}">
+              <a16:creationId xmlns:a16="http://schemas.microsoft.com/office/drawing/2014/main" id="{F368447F-C531-92C9-0376-B1178B60E7A4}"/>
+            </a:ext>
+          </a:extLst>
+        </p:cNvPr>
+        <p:cNvGrpSpPr/>
+        <p:nvPr/>
+      </p:nvGrpSpPr>
+      <p:grpSpPr>
+        <a:xfrm>
+          <a:off x="0" y="0"/>
+          <a:ext cx="0" cy="0"/>
+          <a:chOff x="0" y="0"/>
+          <a:chExt cx="0" cy="0"/>
+        </a:xfrm>
+      </p:grpSpPr>
+      <p:sp>
+        <p:nvSpPr>
+          <p:cNvPr id="2" name="Text Placeholder 1">
+            <a:extLst>
+              <a:ext uri="{FF2B5EF4-FFF2-40B4-BE49-F238E27FC236}">
+                <a16:creationId xmlns:a16="http://schemas.microsoft.com/office/drawing/2014/main" id="{47F55FDA-5B7A-0A15-4B0E-B0E183049B90}"/>
+              </a:ext>
+            </a:extLst>
+          </p:cNvPr>
+          <p:cNvSpPr>
+            <a:spLocks noGrp="1"/>
+          </p:cNvSpPr>
+          <p:nvPr>
+            <p:ph type="body" sz="quarter" idx="10"/>
+          </p:nvPr>
+        </p:nvSpPr>
+        <p:spPr/>
+        <p:txBody>
+          <a:bodyPr/>
+          <a:lstStyle/>
+          <a:p>
+            <a:pPr marL="0" indent="0">
+              <a:buNone/>
+            </a:pPr>
+            <a:endParaRPr lang="en-CA" b="1" dirty="0"/>
+          </a:p>
+          <a:p>
+            <a:pPr marL="0" indent="0">
+              <a:buNone/>
+            </a:pPr>
+            <a:endParaRPr lang="en-CA" b="1" dirty="0"/>
+          </a:p>
+          <a:p>
+            <a:pPr marL="0" indent="0">
+              <a:buNone/>
+            </a:pPr>
+            <a:endParaRPr lang="en-CA" b="1" dirty="0"/>
+          </a:p>
+          <a:p>
+            <a:pPr marL="0" indent="0">
+              <a:buNone/>
+            </a:pPr>
+            <a:endParaRPr lang="en-CA" b="1" dirty="0"/>
+          </a:p>
+          <a:p>
+            <a:pPr marL="0" indent="0">
+              <a:buNone/>
+            </a:pPr>
+            <a:r>
+              <a:rPr lang="en-CA" b="1" dirty="0"/>
+              <a:t>Activity #9.1 – Contribute to a shared repo</a:t>
+            </a:r>
+          </a:p>
+          <a:p>
+            <a:pPr marL="0" indent="0">
+              <a:buNone/>
+            </a:pPr>
+            <a:r>
+              <a:rPr lang="en-CA" b="1" dirty="0"/>
+              <a:t>- </a:t>
+            </a:r>
+            <a:r>
+              <a:rPr lang="en-CA" dirty="0"/>
+              <a:t>Work in teams to contribute to a shared repository</a:t>
+            </a:r>
+            <a:endParaRPr lang="en-CA" b="1" dirty="0"/>
+          </a:p>
+        </p:txBody>
+      </p:sp>
+    </p:spTree>
+    <p:extLst>
+      <p:ext uri="{BB962C8B-B14F-4D97-AF65-F5344CB8AC3E}">
+        <p14:creationId xmlns:p14="http://schemas.microsoft.com/office/powerpoint/2010/main" val="3592577252"/>
+      </p:ext>
+    </p:extLst>
+  </p:cSld>
+  <p:clrMapOvr>
+    <a:masterClrMapping/>
+  </p:clrMapOvr>
+</p:sld>
+</file>
+
+<file path=ppt/slides/slide61.xml><?xml version="1.0" encoding="utf-8"?>
+<p:sld xmlns:a="http://schemas.openxmlformats.org/drawingml/2006/main" xmlns:r="http://schemas.openxmlformats.org/officeDocument/2006/relationships" xmlns:p="http://schemas.openxmlformats.org/presentationml/2006/main" show="0">
   <p:cSld>
     <p:spTree>
       <p:nvGrpSpPr>
@@ -24936,7 +25230,7 @@
 </p:sld>
 </file>
 
-<file path=ppt/slides/slide61.xml><?xml version="1.0" encoding="utf-8"?>
+<file path=ppt/slides/slide62.xml><?xml version="1.0" encoding="utf-8"?>
 <p:sld xmlns:a="http://schemas.openxmlformats.org/drawingml/2006/main" xmlns:r="http://schemas.openxmlformats.org/officeDocument/2006/relationships" xmlns:p="http://schemas.openxmlformats.org/presentationml/2006/main">
   <p:cSld>
     <p:spTree>
@@ -24979,7 +25273,7 @@
             </a:pPr>
             <a:r>
               <a:rPr lang="en-CA" b="1" dirty="0"/>
-              <a:t>Contributing to projects</a:t>
+              <a:t>Contributing to shared projects</a:t>
             </a:r>
           </a:p>
           <a:p>
@@ -25117,7 +25411,7 @@
 </p:sld>
 </file>
 
-<file path=ppt/slides/slide62.xml><?xml version="1.0" encoding="utf-8"?>
+<file path=ppt/slides/slide63.xml><?xml version="1.0" encoding="utf-8"?>
 <p:sld xmlns:a="http://schemas.openxmlformats.org/drawingml/2006/main" xmlns:r="http://schemas.openxmlformats.org/officeDocument/2006/relationships" xmlns:p="http://schemas.openxmlformats.org/presentationml/2006/main">
   <p:cSld>
     <p:spTree>
@@ -25248,7 +25542,7 @@
 </p:sld>
 </file>
 
-<file path=ppt/slides/slide63.xml><?xml version="1.0" encoding="utf-8"?>
+<file path=ppt/slides/slide64.xml><?xml version="1.0" encoding="utf-8"?>
 <p:sld xmlns:a="http://schemas.openxmlformats.org/drawingml/2006/main" xmlns:r="http://schemas.openxmlformats.org/officeDocument/2006/relationships" xmlns:p="http://schemas.openxmlformats.org/presentationml/2006/main">
   <p:cSld>
     <p:spTree>
@@ -27095,7 +27389,7 @@
 </p:sld>
 </file>
 
-<file path=ppt/slides/slide64.xml><?xml version="1.0" encoding="utf-8"?>
+<file path=ppt/slides/slide65.xml><?xml version="1.0" encoding="utf-8"?>
 <p:sld xmlns:a="http://schemas.openxmlformats.org/drawingml/2006/main" xmlns:r="http://schemas.openxmlformats.org/officeDocument/2006/relationships" xmlns:p="http://schemas.openxmlformats.org/presentationml/2006/main">
   <p:cSld>
     <p:spTree>
@@ -27162,7 +27456,7 @@
             </a:pPr>
             <a:r>
               <a:rPr lang="en-CA" b="1" dirty="0"/>
-              <a:t>Activity #9.2 – Fork a Repo and make a Pull Request</a:t>
+              <a:t>Activity #9 – Fork a Repo and make a Pull Request</a:t>
             </a:r>
           </a:p>
           <a:p>
@@ -27194,7 +27488,7 @@
 </p:sld>
 </file>
 
-<file path=ppt/slides/slide65.xml><?xml version="1.0" encoding="utf-8"?>
+<file path=ppt/slides/slide66.xml><?xml version="1.0" encoding="utf-8"?>
 <p:sld xmlns:a="http://schemas.openxmlformats.org/drawingml/2006/main" xmlns:r="http://schemas.openxmlformats.org/officeDocument/2006/relationships" xmlns:p="http://schemas.openxmlformats.org/presentationml/2006/main">
   <p:cSld>
     <p:spTree>
@@ -27239,7 +27533,7 @@
             </a:pPr>
             <a:r>
               <a:rPr lang="en-CA" b="1" dirty="0"/>
-              <a:t>Activity #9.2 – Fork a Repo and make a Pull Request</a:t>
+              <a:t>Activity #9 – Fork a Repo and make a Pull Request</a:t>
             </a:r>
           </a:p>
           <a:p>
@@ -27253,16 +27547,14 @@
             </a:r>
           </a:p>
           <a:p>
-            <a:pPr marL="457088" lvl="1" indent="0" algn="ctr">
-              <a:buNone/>
-            </a:pPr>
-            <a:r>
-              <a:rPr lang="en-CA" sz="1900" dirty="0">
+            <a:pPr lvl="1"/>
+            <a:r>
+              <a:rPr lang="en-CA" sz="2000" dirty="0">
                 <a:hlinkClick r:id="rId2"/>
               </a:rPr>
-              <a:t>https://github.com/ehuan2/GitHub_Practice_Repo</a:t>
-            </a:r>
-            <a:endParaRPr lang="en-CA" sz="1900" dirty="0"/>
+              <a:t>https://github.com/ehuan2/IntroToGitHub</a:t>
+            </a:r>
+            <a:endParaRPr lang="en-CA" sz="2000" dirty="0"/>
           </a:p>
           <a:p>
             <a:pPr marL="514350" indent="-514350">
@@ -27649,7 +27941,7 @@
 </p:sld>
 </file>
 
-<file path=ppt/slides/slide66.xml><?xml version="1.0" encoding="utf-8"?>
+<file path=ppt/slides/slide67.xml><?xml version="1.0" encoding="utf-8"?>
 <p:sld xmlns:a="http://schemas.openxmlformats.org/drawingml/2006/main" xmlns:r="http://schemas.openxmlformats.org/officeDocument/2006/relationships" xmlns:p="http://schemas.openxmlformats.org/presentationml/2006/main">
   <p:cSld>
     <p:spTree>
@@ -28001,7 +28293,7 @@
 </p:sld>
 </file>
 
-<file path=ppt/slides/slide67.xml><?xml version="1.0" encoding="utf-8"?>
+<file path=ppt/slides/slide68.xml><?xml version="1.0" encoding="utf-8"?>
 <p:sld xmlns:a="http://schemas.openxmlformats.org/drawingml/2006/main" xmlns:r="http://schemas.openxmlformats.org/officeDocument/2006/relationships" xmlns:p="http://schemas.openxmlformats.org/presentationml/2006/main">
   <p:cSld>
     <p:spTree>
@@ -28272,7 +28564,7 @@
 </p:sld>
 </file>
 
-<file path=ppt/slides/slide68.xml><?xml version="1.0" encoding="utf-8"?>
+<file path=ppt/slides/slide69.xml><?xml version="1.0" encoding="utf-8"?>
 <p:sld xmlns:a="http://schemas.openxmlformats.org/drawingml/2006/main" xmlns:r="http://schemas.openxmlformats.org/officeDocument/2006/relationships" xmlns:p="http://schemas.openxmlformats.org/presentationml/2006/main">
   <p:cSld>
     <p:spTree>
@@ -28653,64 +28945,6 @@
 </p:sld>
 </file>
 
-<file path=ppt/slides/slide69.xml><?xml version="1.0" encoding="utf-8"?>
-<p:sld xmlns:a="http://schemas.openxmlformats.org/drawingml/2006/main" xmlns:r="http://schemas.openxmlformats.org/officeDocument/2006/relationships" xmlns:p="http://schemas.openxmlformats.org/presentationml/2006/main">
-  <p:cSld>
-    <p:spTree>
-      <p:nvGrpSpPr>
-        <p:cNvPr id="1" name=""/>
-        <p:cNvGrpSpPr/>
-        <p:nvPr/>
-      </p:nvGrpSpPr>
-      <p:grpSpPr>
-        <a:xfrm>
-          <a:off x="0" y="0"/>
-          <a:ext cx="0" cy="0"/>
-          <a:chOff x="0" y="0"/>
-          <a:chExt cx="0" cy="0"/>
-        </a:xfrm>
-      </p:grpSpPr>
-      <p:sp>
-        <p:nvSpPr>
-          <p:cNvPr id="2" name="Title 1">
-            <a:extLst>
-              <a:ext uri="{FF2B5EF4-FFF2-40B4-BE49-F238E27FC236}">
-                <a16:creationId xmlns:a16="http://schemas.microsoft.com/office/drawing/2014/main" id="{36BF4A6E-5D75-77B9-9DA7-DC7FB331562E}"/>
-              </a:ext>
-            </a:extLst>
-          </p:cNvPr>
-          <p:cNvSpPr>
-            <a:spLocks noGrp="1"/>
-          </p:cNvSpPr>
-          <p:nvPr>
-            <p:ph type="title"/>
-          </p:nvPr>
-        </p:nvSpPr>
-        <p:spPr/>
-        <p:txBody>
-          <a:bodyPr/>
-          <a:lstStyle/>
-          <a:p>
-            <a:r>
-              <a:rPr lang="en-CA" dirty="0"/>
-              <a:t>Part V – Miscellaneous Features</a:t>
-            </a:r>
-          </a:p>
-        </p:txBody>
-      </p:sp>
-    </p:spTree>
-    <p:extLst>
-      <p:ext uri="{BB962C8B-B14F-4D97-AF65-F5344CB8AC3E}">
-        <p14:creationId xmlns:p14="http://schemas.microsoft.com/office/powerpoint/2010/main" val="2628845826"/>
-      </p:ext>
-    </p:extLst>
-  </p:cSld>
-  <p:clrMapOvr>
-    <a:masterClrMapping/>
-  </p:clrMapOvr>
-</p:sld>
-</file>
-
 <file path=ppt/slides/slide7.xml><?xml version="1.0" encoding="utf-8"?>
 <p:sld xmlns:a="http://schemas.openxmlformats.org/drawingml/2006/main" xmlns:r="http://schemas.openxmlformats.org/officeDocument/2006/relationships" xmlns:p="http://schemas.openxmlformats.org/presentationml/2006/main">
   <p:cSld>
@@ -28897,6 +29131,64 @@
   <p:cSld>
     <p:spTree>
       <p:nvGrpSpPr>
+        <p:cNvPr id="1" name=""/>
+        <p:cNvGrpSpPr/>
+        <p:nvPr/>
+      </p:nvGrpSpPr>
+      <p:grpSpPr>
+        <a:xfrm>
+          <a:off x="0" y="0"/>
+          <a:ext cx="0" cy="0"/>
+          <a:chOff x="0" y="0"/>
+          <a:chExt cx="0" cy="0"/>
+        </a:xfrm>
+      </p:grpSpPr>
+      <p:sp>
+        <p:nvSpPr>
+          <p:cNvPr id="2" name="Title 1">
+            <a:extLst>
+              <a:ext uri="{FF2B5EF4-FFF2-40B4-BE49-F238E27FC236}">
+                <a16:creationId xmlns:a16="http://schemas.microsoft.com/office/drawing/2014/main" id="{36BF4A6E-5D75-77B9-9DA7-DC7FB331562E}"/>
+              </a:ext>
+            </a:extLst>
+          </p:cNvPr>
+          <p:cNvSpPr>
+            <a:spLocks noGrp="1"/>
+          </p:cNvSpPr>
+          <p:nvPr>
+            <p:ph type="title"/>
+          </p:nvPr>
+        </p:nvSpPr>
+        <p:spPr/>
+        <p:txBody>
+          <a:bodyPr/>
+          <a:lstStyle/>
+          <a:p>
+            <a:r>
+              <a:rPr lang="en-CA" dirty="0"/>
+              <a:t>Part V – Miscellaneous Features</a:t>
+            </a:r>
+          </a:p>
+        </p:txBody>
+      </p:sp>
+    </p:spTree>
+    <p:extLst>
+      <p:ext uri="{BB962C8B-B14F-4D97-AF65-F5344CB8AC3E}">
+        <p14:creationId xmlns:p14="http://schemas.microsoft.com/office/powerpoint/2010/main" val="2628845826"/>
+      </p:ext>
+    </p:extLst>
+  </p:cSld>
+  <p:clrMapOvr>
+    <a:masterClrMapping/>
+  </p:clrMapOvr>
+</p:sld>
+</file>
+
+<file path=ppt/slides/slide71.xml><?xml version="1.0" encoding="utf-8"?>
+<p:sld xmlns:a="http://schemas.openxmlformats.org/drawingml/2006/main" xmlns:r="http://schemas.openxmlformats.org/officeDocument/2006/relationships" xmlns:p="http://schemas.openxmlformats.org/presentationml/2006/main">
+  <p:cSld>
+    <p:spTree>
+      <p:nvGrpSpPr>
         <p:cNvPr id="1" name="">
           <a:extLst>
             <a:ext uri="{FF2B5EF4-FFF2-40B4-BE49-F238E27FC236}">
@@ -28956,7 +29248,7 @@
 </p:sld>
 </file>
 
-<file path=ppt/slides/slide71.xml><?xml version="1.0" encoding="utf-8"?>
+<file path=ppt/slides/slide72.xml><?xml version="1.0" encoding="utf-8"?>
 <p:sld xmlns:a="http://schemas.openxmlformats.org/drawingml/2006/main" xmlns:r="http://schemas.openxmlformats.org/officeDocument/2006/relationships" xmlns:p="http://schemas.openxmlformats.org/presentationml/2006/main">
   <p:cSld>
     <p:spTree>
@@ -29067,7 +29359,7 @@
 </p:sld>
 </file>
 
-<file path=ppt/slides/slide72.xml><?xml version="1.0" encoding="utf-8"?>
+<file path=ppt/slides/slide73.xml><?xml version="1.0" encoding="utf-8"?>
 <p:sld xmlns:a="http://schemas.openxmlformats.org/drawingml/2006/main" xmlns:r="http://schemas.openxmlformats.org/officeDocument/2006/relationships" xmlns:p="http://schemas.openxmlformats.org/presentationml/2006/main">
   <p:cSld>
     <p:spTree>
@@ -29152,7 +29444,7 @@
 </p:sld>
 </file>
 
-<file path=ppt/slides/slide73.xml><?xml version="1.0" encoding="utf-8"?>
+<file path=ppt/slides/slide74.xml><?xml version="1.0" encoding="utf-8"?>
 <p:sld xmlns:a="http://schemas.openxmlformats.org/drawingml/2006/main" xmlns:r="http://schemas.openxmlformats.org/officeDocument/2006/relationships" xmlns:p="http://schemas.openxmlformats.org/presentationml/2006/main" show="0">
   <p:cSld>
     <p:spTree>
@@ -29283,182 +29575,6 @@
     <p:extLst>
       <p:ext uri="{BB962C8B-B14F-4D97-AF65-F5344CB8AC3E}">
         <p14:creationId xmlns:p14="http://schemas.microsoft.com/office/powerpoint/2010/main" val="4223853117"/>
-      </p:ext>
-    </p:extLst>
-  </p:cSld>
-  <p:clrMapOvr>
-    <a:masterClrMapping/>
-  </p:clrMapOvr>
-</p:sld>
-</file>
-
-<file path=ppt/slides/slide74.xml><?xml version="1.0" encoding="utf-8"?>
-<p:sld xmlns:a="http://schemas.openxmlformats.org/drawingml/2006/main" xmlns:r="http://schemas.openxmlformats.org/officeDocument/2006/relationships" xmlns:p="http://schemas.openxmlformats.org/presentationml/2006/main" show="0">
-  <p:cSld>
-    <p:spTree>
-      <p:nvGrpSpPr>
-        <p:cNvPr id="1" name=""/>
-        <p:cNvGrpSpPr/>
-        <p:nvPr/>
-      </p:nvGrpSpPr>
-      <p:grpSpPr>
-        <a:xfrm>
-          <a:off x="0" y="0"/>
-          <a:ext cx="0" cy="0"/>
-          <a:chOff x="0" y="0"/>
-          <a:chExt cx="0" cy="0"/>
-        </a:xfrm>
-      </p:grpSpPr>
-      <p:sp>
-        <p:nvSpPr>
-          <p:cNvPr id="2" name="Text Placeholder 1">
-            <a:extLst>
-              <a:ext uri="{FF2B5EF4-FFF2-40B4-BE49-F238E27FC236}">
-                <a16:creationId xmlns:a16="http://schemas.microsoft.com/office/drawing/2014/main" id="{0CC87135-7AB5-DE33-3BDD-FE5E66CA8354}"/>
-              </a:ext>
-            </a:extLst>
-          </p:cNvPr>
-          <p:cNvSpPr>
-            <a:spLocks noGrp="1"/>
-          </p:cNvSpPr>
-          <p:nvPr>
-            <p:ph type="body" sz="quarter" idx="10"/>
-          </p:nvPr>
-        </p:nvSpPr>
-        <p:spPr/>
-        <p:txBody>
-          <a:bodyPr>
-            <a:normAutofit fontScale="62500" lnSpcReduction="20000"/>
-          </a:bodyPr>
-          <a:lstStyle/>
-          <a:p>
-            <a:pPr marL="0" indent="0">
-              <a:buNone/>
-            </a:pPr>
-            <a:r>
-              <a:rPr lang="en-CA" sz="4000" b="1" dirty="0"/>
-              <a:t>Activity #11 – Commit a new file with git commands</a:t>
-            </a:r>
-          </a:p>
-          <a:p>
-            <a:pPr marL="0" indent="0">
-              <a:buNone/>
-            </a:pPr>
-            <a:endParaRPr lang="en-CA" sz="3800" b="1" dirty="0"/>
-          </a:p>
-          <a:p>
-            <a:pPr marL="514350" indent="-514350">
-              <a:buFont typeface="+mj-lt"/>
-              <a:buAutoNum type="arabicPeriod"/>
-            </a:pPr>
-            <a:r>
-              <a:rPr lang="en-CA" sz="3400" dirty="0"/>
-              <a:t>Create a new txt file in the repo with vim or through your text editor</a:t>
-            </a:r>
-          </a:p>
-          <a:p>
-            <a:pPr marL="514350" indent="-514350">
-              <a:buFont typeface="+mj-lt"/>
-              <a:buAutoNum type="arabicPeriod"/>
-            </a:pPr>
-            <a:r>
-              <a:rPr lang="en-CA" sz="3400" dirty="0"/>
-              <a:t>From the command line, check your repo status: git status 	              (do you see the new file?)</a:t>
-            </a:r>
-          </a:p>
-          <a:p>
-            <a:pPr marL="514350" indent="-514350">
-              <a:buFont typeface="+mj-lt"/>
-              <a:buAutoNum type="arabicPeriod"/>
-            </a:pPr>
-            <a:endParaRPr lang="en-CA" sz="3400" dirty="0"/>
-          </a:p>
-          <a:p>
-            <a:pPr marL="514350" indent="-514350">
-              <a:buFont typeface="+mj-lt"/>
-              <a:buAutoNum type="arabicPeriod"/>
-            </a:pPr>
-            <a:r>
-              <a:rPr lang="en-CA" sz="3400" dirty="0"/>
-              <a:t>Stage the new file: git add </a:t>
-            </a:r>
-            <a:r>
-              <a:rPr lang="en-CA" sz="3400" dirty="0" err="1"/>
-              <a:t>file_name</a:t>
-            </a:r>
-            <a:endParaRPr lang="en-CA" sz="3400" dirty="0"/>
-          </a:p>
-          <a:p>
-            <a:pPr marL="514350" indent="-514350">
-              <a:buFont typeface="+mj-lt"/>
-              <a:buAutoNum type="arabicPeriod"/>
-            </a:pPr>
-            <a:r>
-              <a:rPr lang="en-CA" sz="3400" dirty="0"/>
-              <a:t>Check your repo status: git status</a:t>
-            </a:r>
-          </a:p>
-          <a:p>
-            <a:pPr marL="514350" indent="-514350">
-              <a:buFont typeface="+mj-lt"/>
-              <a:buAutoNum type="arabicPeriod"/>
-            </a:pPr>
-            <a:endParaRPr lang="en-CA" sz="3400" dirty="0"/>
-          </a:p>
-          <a:p>
-            <a:pPr marL="514350" indent="-514350">
-              <a:buFont typeface="+mj-lt"/>
-              <a:buAutoNum type="arabicPeriod"/>
-            </a:pPr>
-            <a:r>
-              <a:rPr lang="en-CA" sz="3400" dirty="0"/>
-              <a:t>Commit the file: git commit </a:t>
-            </a:r>
-            <a:r>
-              <a:rPr lang="en-CA" sz="3400" b="1" dirty="0"/>
-              <a:t>–m </a:t>
-            </a:r>
-            <a:r>
-              <a:rPr lang="en-CA" sz="3400" dirty="0"/>
-              <a:t>“Commit Message”</a:t>
-            </a:r>
-          </a:p>
-          <a:p>
-            <a:pPr marL="514350" indent="-514350">
-              <a:buFont typeface="+mj-lt"/>
-              <a:buAutoNum type="arabicPeriod"/>
-            </a:pPr>
-            <a:r>
-              <a:rPr lang="en-CA" sz="3400" dirty="0"/>
-              <a:t>Check your repo status: git status</a:t>
-            </a:r>
-          </a:p>
-          <a:p>
-            <a:pPr marL="514350" indent="-514350">
-              <a:buFont typeface="+mj-lt"/>
-              <a:buAutoNum type="arabicPeriod"/>
-            </a:pPr>
-            <a:r>
-              <a:rPr lang="en-CA" sz="3400" dirty="0"/>
-              <a:t>Check your Commit History: git log</a:t>
-            </a:r>
-          </a:p>
-          <a:p>
-            <a:pPr marL="514350" indent="-514350">
-              <a:buFont typeface="+mj-lt"/>
-              <a:buAutoNum type="arabicPeriod"/>
-            </a:pPr>
-            <a:r>
-              <a:rPr lang="en-CA" sz="3400" dirty="0"/>
-              <a:t>Rename your branch: git branch –M main</a:t>
-            </a:r>
-          </a:p>
-        </p:txBody>
-      </p:sp>
-    </p:spTree>
-    <p:extLst>
-      <p:ext uri="{BB962C8B-B14F-4D97-AF65-F5344CB8AC3E}">
-        <p14:creationId xmlns:p14="http://schemas.microsoft.com/office/powerpoint/2010/main" val="2502566039"/>
       </p:ext>
     </p:extLst>
   </p:cSld>
@@ -29504,7 +29620,7 @@
         <p:spPr/>
         <p:txBody>
           <a:bodyPr>
-            <a:normAutofit fontScale="92500" lnSpcReduction="20000"/>
+            <a:normAutofit fontScale="62500" lnSpcReduction="20000"/>
           </a:bodyPr>
           <a:lstStyle/>
           <a:p>
@@ -29512,9 +29628,15 @@
               <a:buNone/>
             </a:pPr>
             <a:r>
-              <a:rPr lang="en-CA" sz="3000" b="1" dirty="0"/>
-              <a:t>Activity #12 – Create a new branch</a:t>
-            </a:r>
+              <a:rPr lang="en-CA" sz="4000" b="1" dirty="0"/>
+              <a:t>Activity #11 – Commit a new file with git commands</a:t>
+            </a:r>
+          </a:p>
+          <a:p>
+            <a:pPr marL="0" indent="0">
+              <a:buNone/>
+            </a:pPr>
+            <a:endParaRPr lang="en-CA" sz="3800" b="1" dirty="0"/>
           </a:p>
           <a:p>
             <a:pPr marL="514350" indent="-514350">
@@ -29522,8 +29644,8 @@
               <a:buAutoNum type="arabicPeriod"/>
             </a:pPr>
             <a:r>
-              <a:rPr lang="en-CA" dirty="0"/>
-              <a:t>Check your current branches: git branch</a:t>
+              <a:rPr lang="en-CA" sz="3400" dirty="0"/>
+              <a:t>Create a new txt file in the repo with vim or through your text editor</a:t>
             </a:r>
           </a:p>
           <a:p>
@@ -29531,29 +29653,32 @@
               <a:buFont typeface="+mj-lt"/>
               <a:buAutoNum type="arabicPeriod"/>
             </a:pPr>
-            <a:endParaRPr lang="en-CA" dirty="0"/>
+            <a:r>
+              <a:rPr lang="en-CA" sz="3400" dirty="0"/>
+              <a:t>From the command line, check your repo status: git status 	              (do you see the new file?)</a:t>
+            </a:r>
           </a:p>
           <a:p>
             <a:pPr marL="514350" indent="-514350">
               <a:buFont typeface="+mj-lt"/>
               <a:buAutoNum type="arabicPeriod"/>
             </a:pPr>
-            <a:r>
-              <a:rPr lang="en-CA" dirty="0"/>
-              <a:t>Create new branch: git branch </a:t>
-            </a:r>
-            <a:r>
-              <a:rPr lang="en-CA" dirty="0" err="1"/>
-              <a:t>new_branch_name</a:t>
-            </a:r>
-            <a:endParaRPr lang="en-CA" dirty="0"/>
+            <a:endParaRPr lang="en-CA" sz="3400" dirty="0"/>
           </a:p>
           <a:p>
             <a:pPr marL="514350" indent="-514350">
               <a:buFont typeface="+mj-lt"/>
               <a:buAutoNum type="arabicPeriod"/>
             </a:pPr>
-            <a:endParaRPr lang="en-CA" dirty="0"/>
+            <a:r>
+              <a:rPr lang="en-CA" sz="3400" dirty="0"/>
+              <a:t>Stage the new file: git add </a:t>
+            </a:r>
+            <a:r>
+              <a:rPr lang="en-CA" sz="3400" dirty="0" err="1"/>
+              <a:t>file_name</a:t>
+            </a:r>
+            <a:endParaRPr lang="en-CA" sz="3400" dirty="0"/>
           </a:p>
           <a:p>
             <a:pPr marL="514350" indent="-514350">
@@ -29561,8 +29686,8 @@
               <a:buAutoNum type="arabicPeriod"/>
             </a:pPr>
             <a:r>
-              <a:rPr lang="en-CA" dirty="0"/>
-              <a:t>Check your current branches: git branch</a:t>
+              <a:rPr lang="en-CA" sz="3400" dirty="0"/>
+              <a:t>Check your repo status: git status</a:t>
             </a:r>
           </a:p>
           <a:p>
@@ -29570,7 +29695,7 @@
               <a:buFont typeface="+mj-lt"/>
               <a:buAutoNum type="arabicPeriod"/>
             </a:pPr>
-            <a:endParaRPr lang="en-CA" dirty="0"/>
+            <a:endParaRPr lang="en-CA" sz="3400" dirty="0"/>
           </a:p>
           <a:p>
             <a:pPr marL="514350" indent="-514350">
@@ -29578,21 +29703,27 @@
               <a:buAutoNum type="arabicPeriod"/>
             </a:pPr>
             <a:r>
-              <a:rPr lang="en-CA" dirty="0"/>
-              <a:t>Switch to new branch: git checkout </a:t>
-            </a:r>
-            <a:r>
-              <a:rPr lang="en-CA" dirty="0" err="1"/>
-              <a:t>new_branch_name</a:t>
-            </a:r>
-            <a:endParaRPr lang="en-CA" dirty="0"/>
+              <a:rPr lang="en-CA" sz="3400" dirty="0"/>
+              <a:t>Commit the file: git commit </a:t>
+            </a:r>
+            <a:r>
+              <a:rPr lang="en-CA" sz="3400" b="1" dirty="0"/>
+              <a:t>–m </a:t>
+            </a:r>
+            <a:r>
+              <a:rPr lang="en-CA" sz="3400" dirty="0"/>
+              <a:t>“Commit Message”</a:t>
+            </a:r>
           </a:p>
           <a:p>
             <a:pPr marL="514350" indent="-514350">
               <a:buFont typeface="+mj-lt"/>
               <a:buAutoNum type="arabicPeriod"/>
             </a:pPr>
-            <a:endParaRPr lang="en-CA" dirty="0"/>
+            <a:r>
+              <a:rPr lang="en-CA" sz="3400" dirty="0"/>
+              <a:t>Check your repo status: git status</a:t>
+            </a:r>
           </a:p>
           <a:p>
             <a:pPr marL="514350" indent="-514350">
@@ -29600,8 +29731,8 @@
               <a:buAutoNum type="arabicPeriod"/>
             </a:pPr>
             <a:r>
-              <a:rPr lang="en-CA" dirty="0"/>
-              <a:t>Edit your file and commit it</a:t>
+              <a:rPr lang="en-CA" sz="3400" dirty="0"/>
+              <a:t>Check your Commit History: git log</a:t>
             </a:r>
           </a:p>
           <a:p>
@@ -29609,16 +29740,9 @@
               <a:buFont typeface="+mj-lt"/>
               <a:buAutoNum type="arabicPeriod"/>
             </a:pPr>
-            <a:endParaRPr lang="en-CA" dirty="0"/>
-          </a:p>
-          <a:p>
-            <a:pPr marL="514350" indent="-514350">
-              <a:buFont typeface="+mj-lt"/>
-              <a:buAutoNum type="arabicPeriod"/>
-            </a:pPr>
-            <a:r>
-              <a:rPr lang="en-CA" dirty="0"/>
-              <a:t>Check your commit history: git log</a:t>
+            <a:r>
+              <a:rPr lang="en-CA" sz="3400" dirty="0"/>
+              <a:t>Rename your branch: git branch –M main</a:t>
             </a:r>
           </a:p>
         </p:txBody>
@@ -29626,7 +29750,7 @@
     </p:spTree>
     <p:extLst>
       <p:ext uri="{BB962C8B-B14F-4D97-AF65-F5344CB8AC3E}">
-        <p14:creationId xmlns:p14="http://schemas.microsoft.com/office/powerpoint/2010/main" val="2074610716"/>
+        <p14:creationId xmlns:p14="http://schemas.microsoft.com/office/powerpoint/2010/main" val="2502566039"/>
       </p:ext>
     </p:extLst>
   </p:cSld>
@@ -29669,22 +29793,19 @@
             <p:ph type="body" sz="quarter" idx="10"/>
           </p:nvPr>
         </p:nvSpPr>
-        <p:spPr>
-          <a:xfrm>
-            <a:off x="242628" y="1449307"/>
-            <a:ext cx="8658743" cy="4924350"/>
-          </a:xfrm>
-        </p:spPr>
+        <p:spPr/>
         <p:txBody>
-          <a:bodyPr/>
+          <a:bodyPr>
+            <a:normAutofit fontScale="92500" lnSpcReduction="20000"/>
+          </a:bodyPr>
           <a:lstStyle/>
           <a:p>
             <a:pPr marL="0" indent="0">
               <a:buNone/>
             </a:pPr>
             <a:r>
-              <a:rPr lang="en-CA" b="1" dirty="0"/>
-              <a:t>Activity #13.1 – Revert a Modification/Commit</a:t>
+              <a:rPr lang="en-CA" sz="3000" b="1" dirty="0"/>
+              <a:t>Activity #12 – Create a new branch</a:t>
             </a:r>
           </a:p>
           <a:p>
@@ -29694,7 +29815,7 @@
             </a:pPr>
             <a:r>
               <a:rPr lang="en-CA" dirty="0"/>
-              <a:t>Make a change to a file</a:t>
+              <a:t>Check your current branches: git branch</a:t>
             </a:r>
           </a:p>
           <a:p>
@@ -29702,10 +29823,7 @@
               <a:buFont typeface="+mj-lt"/>
               <a:buAutoNum type="arabicPeriod"/>
             </a:pPr>
-            <a:r>
-              <a:rPr lang="en-CA" dirty="0"/>
-              <a:t>Check the repo status: git status</a:t>
-            </a:r>
+            <a:endParaRPr lang="en-CA" dirty="0"/>
           </a:p>
           <a:p>
             <a:pPr marL="514350" indent="-514350">
@@ -29714,11 +29832,11 @@
             </a:pPr>
             <a:r>
               <a:rPr lang="en-CA" dirty="0"/>
-              <a:t>Restore the previous version of file: git restore </a:t>
+              <a:t>Create new branch: git branch </a:t>
             </a:r>
             <a:r>
               <a:rPr lang="en-CA" dirty="0" err="1"/>
-              <a:t>file_name</a:t>
+              <a:t>new_branch_name</a:t>
             </a:r>
             <a:endParaRPr lang="en-CA" dirty="0"/>
           </a:p>
@@ -29736,31 +29854,14 @@
             </a:pPr>
             <a:r>
               <a:rPr lang="en-CA" dirty="0"/>
-              <a:t>Make the change again, but stage it this time: git add </a:t>
-            </a:r>
-            <a:r>
-              <a:rPr lang="en-CA" dirty="0" err="1"/>
-              <a:t>file_name</a:t>
-            </a:r>
-            <a:endParaRPr lang="en-CA" dirty="0"/>
+              <a:t>Check your current branches: git branch</a:t>
+            </a:r>
           </a:p>
           <a:p>
             <a:pPr marL="514350" indent="-514350">
               <a:buFont typeface="+mj-lt"/>
               <a:buAutoNum type="arabicPeriod"/>
             </a:pPr>
-            <a:r>
-              <a:rPr lang="en-CA" dirty="0" err="1"/>
-              <a:t>Unstage</a:t>
-            </a:r>
-            <a:r>
-              <a:rPr lang="en-CA" dirty="0"/>
-              <a:t> the file: git reset </a:t>
-            </a:r>
-            <a:r>
-              <a:rPr lang="en-CA" dirty="0" err="1"/>
-              <a:t>file_name</a:t>
-            </a:r>
             <a:endParaRPr lang="en-CA" dirty="0"/>
           </a:p>
           <a:p>
@@ -29768,6 +29869,14 @@
               <a:buFont typeface="+mj-lt"/>
               <a:buAutoNum type="arabicPeriod"/>
             </a:pPr>
+            <a:r>
+              <a:rPr lang="en-CA" dirty="0"/>
+              <a:t>Switch to new branch: git checkout </a:t>
+            </a:r>
+            <a:r>
+              <a:rPr lang="en-CA" dirty="0" err="1"/>
+              <a:t>new_branch_name</a:t>
+            </a:r>
             <a:endParaRPr lang="en-CA" dirty="0"/>
           </a:p>
           <a:p>
@@ -29782,14 +29891,34 @@
               <a:buFont typeface="+mj-lt"/>
               <a:buAutoNum type="arabicPeriod"/>
             </a:pPr>
+            <a:r>
+              <a:rPr lang="en-CA" dirty="0"/>
+              <a:t>Edit your file and commit it</a:t>
+            </a:r>
+          </a:p>
+          <a:p>
+            <a:pPr marL="514350" indent="-514350">
+              <a:buFont typeface="+mj-lt"/>
+              <a:buAutoNum type="arabicPeriod"/>
+            </a:pPr>
             <a:endParaRPr lang="en-CA" dirty="0"/>
+          </a:p>
+          <a:p>
+            <a:pPr marL="514350" indent="-514350">
+              <a:buFont typeface="+mj-lt"/>
+              <a:buAutoNum type="arabicPeriod"/>
+            </a:pPr>
+            <a:r>
+              <a:rPr lang="en-CA" dirty="0"/>
+              <a:t>Check your commit history: git log</a:t>
+            </a:r>
           </a:p>
         </p:txBody>
       </p:sp>
     </p:spTree>
     <p:extLst>
       <p:ext uri="{BB962C8B-B14F-4D97-AF65-F5344CB8AC3E}">
-        <p14:creationId xmlns:p14="http://schemas.microsoft.com/office/powerpoint/2010/main" val="1880580410"/>
+        <p14:creationId xmlns:p14="http://schemas.microsoft.com/office/powerpoint/2010/main" val="2074610716"/>
       </p:ext>
     </p:extLst>
   </p:cSld>
@@ -29847,7 +29976,7 @@
             </a:pPr>
             <a:r>
               <a:rPr lang="en-CA" b="1" dirty="0"/>
-              <a:t>Activity #13.2 – Revert a Modification/Commit</a:t>
+              <a:t>Activity #13.1 – Revert a Modification/Commit</a:t>
             </a:r>
           </a:p>
           <a:p>
@@ -29857,40 +29986,8 @@
             </a:pPr>
             <a:r>
               <a:rPr lang="en-CA" dirty="0"/>
-              <a:t>Make a change and commit it</a:t>
-            </a:r>
-          </a:p>
-          <a:p>
-            <a:pPr marL="971438" lvl="1" indent="-514350">
-              <a:buFont typeface="+mj-lt"/>
-              <a:buAutoNum type="arabicPeriod"/>
-            </a:pPr>
-            <a:r>
-              <a:rPr lang="en-CA" dirty="0"/>
-              <a:t>git add </a:t>
-            </a:r>
-            <a:r>
-              <a:rPr lang="en-CA" dirty="0" err="1"/>
-              <a:t>file_name</a:t>
-            </a:r>
-            <a:endParaRPr lang="en-CA" dirty="0"/>
-          </a:p>
-          <a:p>
-            <a:pPr marL="971438" lvl="1" indent="-514350">
-              <a:buFont typeface="+mj-lt"/>
-              <a:buAutoNum type="arabicPeriod"/>
-            </a:pPr>
-            <a:r>
-              <a:rPr lang="en-CA" dirty="0"/>
-              <a:t>git commit –m “commit message” </a:t>
-            </a:r>
-          </a:p>
-          <a:p>
-            <a:pPr marL="971438" lvl="1" indent="-514350">
-              <a:buFont typeface="+mj-lt"/>
-              <a:buAutoNum type="arabicPeriod"/>
-            </a:pPr>
-            <a:endParaRPr lang="en-CA" dirty="0"/>
+              <a:t>Make a change to a file</a:t>
+            </a:r>
           </a:p>
           <a:p>
             <a:pPr marL="514350" indent="-514350">
@@ -29899,7 +29996,7 @@
             </a:pPr>
             <a:r>
               <a:rPr lang="en-CA" dirty="0"/>
-              <a:t>Get the commit ID from your commit history: git log</a:t>
+              <a:t>Check the repo status: git status</a:t>
             </a:r>
           </a:p>
           <a:p>
@@ -29907,6 +30004,14 @@
               <a:buFont typeface="+mj-lt"/>
               <a:buAutoNum type="arabicPeriod"/>
             </a:pPr>
+            <a:r>
+              <a:rPr lang="en-CA" dirty="0"/>
+              <a:t>Restore the previous version of file: git restore </a:t>
+            </a:r>
+            <a:r>
+              <a:rPr lang="en-CA" dirty="0" err="1"/>
+              <a:t>file_name</a:t>
+            </a:r>
             <a:endParaRPr lang="en-CA" dirty="0"/>
           </a:p>
           <a:p>
@@ -29914,14 +30019,6 @@
               <a:buFont typeface="+mj-lt"/>
               <a:buAutoNum type="arabicPeriod"/>
             </a:pPr>
-            <a:r>
-              <a:rPr lang="en-CA" dirty="0"/>
-              <a:t>Revert your current commit: git revert </a:t>
-            </a:r>
-            <a:r>
-              <a:rPr lang="en-CA" dirty="0" err="1"/>
-              <a:t>commit_id</a:t>
-            </a:r>
             <a:endParaRPr lang="en-CA" dirty="0"/>
           </a:p>
           <a:p>
@@ -29929,6 +30026,14 @@
               <a:buFont typeface="+mj-lt"/>
               <a:buAutoNum type="arabicPeriod"/>
             </a:pPr>
+            <a:r>
+              <a:rPr lang="en-CA" dirty="0"/>
+              <a:t>Make the change again, but stage it this time: git add </a:t>
+            </a:r>
+            <a:r>
+              <a:rPr lang="en-CA" dirty="0" err="1"/>
+              <a:t>file_name</a:t>
+            </a:r>
             <a:endParaRPr lang="en-CA" dirty="0"/>
           </a:p>
           <a:p>
@@ -29937,9 +30042,25 @@
               <a:buAutoNum type="arabicPeriod"/>
             </a:pPr>
             <a:r>
-              <a:rPr lang="en-CA" dirty="0"/>
-              <a:t>Check your file: have the changes been reverted?</a:t>
-            </a:r>
+              <a:rPr lang="en-CA" dirty="0" err="1"/>
+              <a:t>Unstage</a:t>
+            </a:r>
+            <a:r>
+              <a:rPr lang="en-CA" dirty="0"/>
+              <a:t> the file: git reset </a:t>
+            </a:r>
+            <a:r>
+              <a:rPr lang="en-CA" dirty="0" err="1"/>
+              <a:t>file_name</a:t>
+            </a:r>
+            <a:endParaRPr lang="en-CA" dirty="0"/>
+          </a:p>
+          <a:p>
+            <a:pPr marL="514350" indent="-514350">
+              <a:buFont typeface="+mj-lt"/>
+              <a:buAutoNum type="arabicPeriod"/>
+            </a:pPr>
+            <a:endParaRPr lang="en-CA" dirty="0"/>
           </a:p>
           <a:p>
             <a:pPr marL="514350" indent="-514350">
@@ -29960,7 +30081,7 @@
     </p:spTree>
     <p:extLst>
       <p:ext uri="{BB962C8B-B14F-4D97-AF65-F5344CB8AC3E}">
-        <p14:creationId xmlns:p14="http://schemas.microsoft.com/office/powerpoint/2010/main" val="948834899"/>
+        <p14:creationId xmlns:p14="http://schemas.microsoft.com/office/powerpoint/2010/main" val="1880580410"/>
       </p:ext>
     </p:extLst>
   </p:cSld>
@@ -30003,11 +30124,14 @@
             <p:ph type="body" sz="quarter" idx="10"/>
           </p:nvPr>
         </p:nvSpPr>
-        <p:spPr/>
+        <p:spPr>
+          <a:xfrm>
+            <a:off x="242628" y="1449307"/>
+            <a:ext cx="8658743" cy="4924350"/>
+          </a:xfrm>
+        </p:spPr>
         <p:txBody>
-          <a:bodyPr>
-            <a:normAutofit fontScale="92500" lnSpcReduction="10000"/>
-          </a:bodyPr>
+          <a:bodyPr/>
           <a:lstStyle/>
           <a:p>
             <a:pPr marL="0" indent="0">
@@ -30015,14 +30139,8 @@
             </a:pPr>
             <a:r>
               <a:rPr lang="en-CA" b="1" dirty="0"/>
-              <a:t>Activity #14.1 – Push to Remote Repository</a:t>
-            </a:r>
-          </a:p>
-          <a:p>
-            <a:pPr marL="0" indent="0">
-              <a:buNone/>
-            </a:pPr>
-            <a:endParaRPr lang="en-CA" b="1" dirty="0"/>
+              <a:t>Activity #13.2 – Revert a Modification/Commit</a:t>
+            </a:r>
           </a:p>
           <a:p>
             <a:pPr marL="514350" indent="-514350">
@@ -30031,8 +30149,40 @@
             </a:pPr>
             <a:r>
               <a:rPr lang="en-CA" dirty="0"/>
-              <a:t>On the GitHub website, click on your profile in the top right corner and select “settings”</a:t>
-            </a:r>
+              <a:t>Make a change and commit it</a:t>
+            </a:r>
+          </a:p>
+          <a:p>
+            <a:pPr marL="971438" lvl="1" indent="-514350">
+              <a:buFont typeface="+mj-lt"/>
+              <a:buAutoNum type="arabicPeriod"/>
+            </a:pPr>
+            <a:r>
+              <a:rPr lang="en-CA" dirty="0"/>
+              <a:t>git add </a:t>
+            </a:r>
+            <a:r>
+              <a:rPr lang="en-CA" dirty="0" err="1"/>
+              <a:t>file_name</a:t>
+            </a:r>
+            <a:endParaRPr lang="en-CA" dirty="0"/>
+          </a:p>
+          <a:p>
+            <a:pPr marL="971438" lvl="1" indent="-514350">
+              <a:buFont typeface="+mj-lt"/>
+              <a:buAutoNum type="arabicPeriod"/>
+            </a:pPr>
+            <a:r>
+              <a:rPr lang="en-CA" dirty="0"/>
+              <a:t>git commit –m “commit message” </a:t>
+            </a:r>
+          </a:p>
+          <a:p>
+            <a:pPr marL="971438" lvl="1" indent="-514350">
+              <a:buFont typeface="+mj-lt"/>
+              <a:buAutoNum type="arabicPeriod"/>
+            </a:pPr>
+            <a:endParaRPr lang="en-CA" dirty="0"/>
           </a:p>
           <a:p>
             <a:pPr marL="514350" indent="-514350">
@@ -30041,7 +30191,7 @@
             </a:pPr>
             <a:r>
               <a:rPr lang="en-CA" dirty="0"/>
-              <a:t>Select “Developer settings” at the bottom of the page</a:t>
+              <a:t>Get the commit ID from your commit history: git log</a:t>
             </a:r>
           </a:p>
           <a:p>
@@ -30058,42 +30208,51 @@
             </a:pPr>
             <a:r>
               <a:rPr lang="en-CA" dirty="0"/>
-              <a:t>Under the “Personal access tokens” menu, click generate new token.</a:t>
-            </a:r>
+              <a:t>Revert your current commit: git revert </a:t>
+            </a:r>
+            <a:r>
+              <a:rPr lang="en-CA" dirty="0" err="1"/>
+              <a:t>commit_id</a:t>
+            </a:r>
+            <a:endParaRPr lang="en-CA" dirty="0"/>
           </a:p>
           <a:p>
             <a:pPr marL="514350" indent="-514350">
               <a:buFont typeface="+mj-lt"/>
               <a:buAutoNum type="arabicPeriod"/>
             </a:pPr>
-            <a:r>
-              <a:rPr lang="en-CA" dirty="0"/>
-              <a:t>Select the “repo” scope and generate token.</a:t>
-            </a:r>
+            <a:endParaRPr lang="en-CA" dirty="0"/>
           </a:p>
           <a:p>
             <a:pPr marL="514350" indent="-514350">
               <a:buFont typeface="+mj-lt"/>
               <a:buAutoNum type="arabicPeriod"/>
             </a:pPr>
-            <a:endParaRPr lang="en-CA" dirty="0"/>
+            <a:r>
+              <a:rPr lang="en-CA" dirty="0"/>
+              <a:t>Check your file: have the changes been reverted?</a:t>
+            </a:r>
           </a:p>
           <a:p>
             <a:pPr marL="514350" indent="-514350">
               <a:buFont typeface="+mj-lt"/>
               <a:buAutoNum type="arabicPeriod"/>
             </a:pPr>
-            <a:r>
-              <a:rPr lang="en-CA" dirty="0"/>
-              <a:t>SAVE the token somewhere (or you will have to make a new one)</a:t>
-            </a:r>
+            <a:endParaRPr lang="en-CA" dirty="0"/>
+          </a:p>
+          <a:p>
+            <a:pPr marL="514350" indent="-514350">
+              <a:buFont typeface="+mj-lt"/>
+              <a:buAutoNum type="arabicPeriod"/>
+            </a:pPr>
+            <a:endParaRPr lang="en-CA" dirty="0"/>
           </a:p>
         </p:txBody>
       </p:sp>
     </p:spTree>
     <p:extLst>
       <p:ext uri="{BB962C8B-B14F-4D97-AF65-F5344CB8AC3E}">
-        <p14:creationId xmlns:p14="http://schemas.microsoft.com/office/powerpoint/2010/main" val="2536054258"/>
+        <p14:creationId xmlns:p14="http://schemas.microsoft.com/office/powerpoint/2010/main" val="948834899"/>
       </p:ext>
     </p:extLst>
   </p:cSld>
@@ -30138,7 +30297,9 @@
         </p:nvSpPr>
         <p:spPr/>
         <p:txBody>
-          <a:bodyPr/>
+          <a:bodyPr>
+            <a:normAutofit fontScale="92500" lnSpcReduction="10000"/>
+          </a:bodyPr>
           <a:lstStyle/>
           <a:p>
             <a:pPr marL="0" indent="0">
@@ -30146,8 +30307,14 @@
             </a:pPr>
             <a:r>
               <a:rPr lang="en-CA" b="1" dirty="0"/>
-              <a:t>Activity #14.2 – Push to Remote Repository</a:t>
-            </a:r>
+              <a:t>Activity #14.1 – Push to Remote Repository</a:t>
+            </a:r>
+          </a:p>
+          <a:p>
+            <a:pPr marL="0" indent="0">
+              <a:buNone/>
+            </a:pPr>
+            <a:endParaRPr lang="en-CA" b="1" dirty="0"/>
           </a:p>
           <a:p>
             <a:pPr marL="514350" indent="-514350">
@@ -30156,35 +30323,8 @@
             </a:pPr>
             <a:r>
               <a:rPr lang="en-CA" dirty="0"/>
-              <a:t>On the GitHub website, create a new repository</a:t>
-            </a:r>
-          </a:p>
-          <a:p>
-            <a:pPr marL="971438" lvl="1" indent="-514350">
-              <a:buFont typeface="+mj-lt"/>
-              <a:buAutoNum type="arabicPeriod"/>
-            </a:pPr>
-            <a:r>
-              <a:rPr lang="en-CA" dirty="0"/>
-              <a:t>Do NOT create a README file</a:t>
-            </a:r>
-          </a:p>
-          <a:p>
-            <a:pPr marL="971438" lvl="1" indent="-514350">
-              <a:buFont typeface="+mj-lt"/>
-              <a:buAutoNum type="arabicPeriod"/>
-            </a:pPr>
-            <a:r>
-              <a:rPr lang="en-CA" dirty="0"/>
-              <a:t>Copy paste the repo’s URL</a:t>
-            </a:r>
-          </a:p>
-          <a:p>
-            <a:pPr marL="971438" lvl="1" indent="-514350">
-              <a:buFont typeface="+mj-lt"/>
-              <a:buAutoNum type="arabicPeriod"/>
-            </a:pPr>
-            <a:endParaRPr lang="en-CA" dirty="0"/>
+              <a:t>On the GitHub website, click on your profile in the top right corner and select “settings”</a:t>
+            </a:r>
           </a:p>
           <a:p>
             <a:pPr marL="514350" indent="-514350">
@@ -30193,7 +30333,7 @@
             </a:pPr>
             <a:r>
               <a:rPr lang="en-CA" dirty="0"/>
-              <a:t>In the command line, link your local and remote repo:	git remote add origin URL</a:t>
+              <a:t>Select “Developer settings” at the bottom of the page</a:t>
             </a:r>
           </a:p>
           <a:p>
@@ -30210,7 +30350,7 @@
             </a:pPr>
             <a:r>
               <a:rPr lang="en-CA" dirty="0"/>
-              <a:t>Push your main branch: git push -u origin main</a:t>
+              <a:t>Under the “Personal access tokens” menu, click generate new token.</a:t>
             </a:r>
           </a:p>
           <a:p>
@@ -30220,7 +30360,24 @@
             </a:pPr>
             <a:r>
               <a:rPr lang="en-CA" dirty="0"/>
-              <a:t>Check your remote repo: are the files there?</a:t>
+              <a:t>Select the “repo” scope and generate token.</a:t>
+            </a:r>
+          </a:p>
+          <a:p>
+            <a:pPr marL="514350" indent="-514350">
+              <a:buFont typeface="+mj-lt"/>
+              <a:buAutoNum type="arabicPeriod"/>
+            </a:pPr>
+            <a:endParaRPr lang="en-CA" dirty="0"/>
+          </a:p>
+          <a:p>
+            <a:pPr marL="514350" indent="-514350">
+              <a:buFont typeface="+mj-lt"/>
+              <a:buAutoNum type="arabicPeriod"/>
+            </a:pPr>
+            <a:r>
+              <a:rPr lang="en-CA" dirty="0"/>
+              <a:t>SAVE the token somewhere (or you will have to make a new one)</a:t>
             </a:r>
           </a:p>
         </p:txBody>
@@ -30228,7 +30385,7 @@
     </p:spTree>
     <p:extLst>
       <p:ext uri="{BB962C8B-B14F-4D97-AF65-F5344CB8AC3E}">
-        <p14:creationId xmlns:p14="http://schemas.microsoft.com/office/powerpoint/2010/main" val="4268438258"/>
+        <p14:creationId xmlns:p14="http://schemas.microsoft.com/office/powerpoint/2010/main" val="2536054258"/>
       </p:ext>
     </p:extLst>
   </p:cSld>
@@ -30457,6 +30614,141 @@
 </file>
 
 <file path=ppt/slides/slide80.xml><?xml version="1.0" encoding="utf-8"?>
+<p:sld xmlns:a="http://schemas.openxmlformats.org/drawingml/2006/main" xmlns:r="http://schemas.openxmlformats.org/officeDocument/2006/relationships" xmlns:p="http://schemas.openxmlformats.org/presentationml/2006/main" show="0">
+  <p:cSld>
+    <p:spTree>
+      <p:nvGrpSpPr>
+        <p:cNvPr id="1" name=""/>
+        <p:cNvGrpSpPr/>
+        <p:nvPr/>
+      </p:nvGrpSpPr>
+      <p:grpSpPr>
+        <a:xfrm>
+          <a:off x="0" y="0"/>
+          <a:ext cx="0" cy="0"/>
+          <a:chOff x="0" y="0"/>
+          <a:chExt cx="0" cy="0"/>
+        </a:xfrm>
+      </p:grpSpPr>
+      <p:sp>
+        <p:nvSpPr>
+          <p:cNvPr id="2" name="Text Placeholder 1">
+            <a:extLst>
+              <a:ext uri="{FF2B5EF4-FFF2-40B4-BE49-F238E27FC236}">
+                <a16:creationId xmlns:a16="http://schemas.microsoft.com/office/drawing/2014/main" id="{0CC87135-7AB5-DE33-3BDD-FE5E66CA8354}"/>
+              </a:ext>
+            </a:extLst>
+          </p:cNvPr>
+          <p:cNvSpPr>
+            <a:spLocks noGrp="1"/>
+          </p:cNvSpPr>
+          <p:nvPr>
+            <p:ph type="body" sz="quarter" idx="10"/>
+          </p:nvPr>
+        </p:nvSpPr>
+        <p:spPr/>
+        <p:txBody>
+          <a:bodyPr/>
+          <a:lstStyle/>
+          <a:p>
+            <a:pPr marL="0" indent="0">
+              <a:buNone/>
+            </a:pPr>
+            <a:r>
+              <a:rPr lang="en-CA" b="1" dirty="0"/>
+              <a:t>Activity #14.2 – Push to Remote Repository</a:t>
+            </a:r>
+          </a:p>
+          <a:p>
+            <a:pPr marL="514350" indent="-514350">
+              <a:buFont typeface="+mj-lt"/>
+              <a:buAutoNum type="arabicPeriod"/>
+            </a:pPr>
+            <a:r>
+              <a:rPr lang="en-CA" dirty="0"/>
+              <a:t>On the GitHub website, create a new repository</a:t>
+            </a:r>
+          </a:p>
+          <a:p>
+            <a:pPr marL="971438" lvl="1" indent="-514350">
+              <a:buFont typeface="+mj-lt"/>
+              <a:buAutoNum type="arabicPeriod"/>
+            </a:pPr>
+            <a:r>
+              <a:rPr lang="en-CA" dirty="0"/>
+              <a:t>Do NOT create a README file</a:t>
+            </a:r>
+          </a:p>
+          <a:p>
+            <a:pPr marL="971438" lvl="1" indent="-514350">
+              <a:buFont typeface="+mj-lt"/>
+              <a:buAutoNum type="arabicPeriod"/>
+            </a:pPr>
+            <a:r>
+              <a:rPr lang="en-CA" dirty="0"/>
+              <a:t>Copy paste the repo’s URL</a:t>
+            </a:r>
+          </a:p>
+          <a:p>
+            <a:pPr marL="971438" lvl="1" indent="-514350">
+              <a:buFont typeface="+mj-lt"/>
+              <a:buAutoNum type="arabicPeriod"/>
+            </a:pPr>
+            <a:endParaRPr lang="en-CA" dirty="0"/>
+          </a:p>
+          <a:p>
+            <a:pPr marL="514350" indent="-514350">
+              <a:buFont typeface="+mj-lt"/>
+              <a:buAutoNum type="arabicPeriod"/>
+            </a:pPr>
+            <a:r>
+              <a:rPr lang="en-CA" dirty="0"/>
+              <a:t>In the command line, link your local and remote repo:	git remote add origin URL</a:t>
+            </a:r>
+          </a:p>
+          <a:p>
+            <a:pPr marL="514350" indent="-514350">
+              <a:buFont typeface="+mj-lt"/>
+              <a:buAutoNum type="arabicPeriod"/>
+            </a:pPr>
+            <a:endParaRPr lang="en-CA" dirty="0"/>
+          </a:p>
+          <a:p>
+            <a:pPr marL="514350" indent="-514350">
+              <a:buFont typeface="+mj-lt"/>
+              <a:buAutoNum type="arabicPeriod"/>
+            </a:pPr>
+            <a:r>
+              <a:rPr lang="en-CA" dirty="0"/>
+              <a:t>Push your main branch: git push -u origin main</a:t>
+            </a:r>
+          </a:p>
+          <a:p>
+            <a:pPr marL="514350" indent="-514350">
+              <a:buFont typeface="+mj-lt"/>
+              <a:buAutoNum type="arabicPeriod"/>
+            </a:pPr>
+            <a:r>
+              <a:rPr lang="en-CA" dirty="0"/>
+              <a:t>Check your remote repo: are the files there?</a:t>
+            </a:r>
+          </a:p>
+        </p:txBody>
+      </p:sp>
+    </p:spTree>
+    <p:extLst>
+      <p:ext uri="{BB962C8B-B14F-4D97-AF65-F5344CB8AC3E}">
+        <p14:creationId xmlns:p14="http://schemas.microsoft.com/office/powerpoint/2010/main" val="4268438258"/>
+      </p:ext>
+    </p:extLst>
+  </p:cSld>
+  <p:clrMapOvr>
+    <a:masterClrMapping/>
+  </p:clrMapOvr>
+</p:sld>
+</file>
+
+<file path=ppt/slides/slide81.xml><?xml version="1.0" encoding="utf-8"?>
 <p:sld xmlns:a="http://schemas.openxmlformats.org/drawingml/2006/main" xmlns:r="http://schemas.openxmlformats.org/officeDocument/2006/relationships" xmlns:p="http://schemas.openxmlformats.org/presentationml/2006/main">
   <p:cSld>
     <p:spTree>
@@ -30514,7 +30806,7 @@
 </p:sld>
 </file>
 
-<file path=ppt/slides/slide81.xml><?xml version="1.0" encoding="utf-8"?>
+<file path=ppt/slides/slide82.xml><?xml version="1.0" encoding="utf-8"?>
 <p:sld xmlns:a="http://schemas.openxmlformats.org/drawingml/2006/main" xmlns:r="http://schemas.openxmlformats.org/officeDocument/2006/relationships" xmlns:p="http://schemas.openxmlformats.org/presentationml/2006/main">
   <p:cSld>
     <p:spTree>
@@ -30639,7 +30931,7 @@
 </p:sld>
 </file>
 
-<file path=ppt/slides/slide82.xml><?xml version="1.0" encoding="utf-8"?>
+<file path=ppt/slides/slide83.xml><?xml version="1.0" encoding="utf-8"?>
 <p:sld xmlns:a="http://schemas.openxmlformats.org/drawingml/2006/main" xmlns:r="http://schemas.openxmlformats.org/officeDocument/2006/relationships" xmlns:p="http://schemas.openxmlformats.org/presentationml/2006/main">
   <p:cSld>
     <p:spTree>
@@ -30924,7 +31216,7 @@
 </p:sld>
 </file>
 
-<file path=ppt/slides/slide83.xml><?xml version="1.0" encoding="utf-8"?>
+<file path=ppt/slides/slide84.xml><?xml version="1.0" encoding="utf-8"?>
 <p:sld xmlns:a="http://schemas.openxmlformats.org/drawingml/2006/main" xmlns:r="http://schemas.openxmlformats.org/officeDocument/2006/relationships" xmlns:p="http://schemas.openxmlformats.org/presentationml/2006/main">
   <p:cSld>
     <p:spTree>
@@ -31021,7 +31313,7 @@
 </p:sld>
 </file>
 
-<file path=ppt/slides/slide84.xml><?xml version="1.0" encoding="utf-8"?>
+<file path=ppt/slides/slide85.xml><?xml version="1.0" encoding="utf-8"?>
 <p:sld xmlns:a="http://schemas.openxmlformats.org/drawingml/2006/main" xmlns:r="http://schemas.openxmlformats.org/officeDocument/2006/relationships" xmlns:p="http://schemas.openxmlformats.org/presentationml/2006/main">
   <p:cSld>
     <p:spTree>

</xml_diff>